<commit_message>
chore(present): Deck durchgehend Dark Mode
Co-Authored-By: Claude Opus 4.8 <noreply@anthropic.com>
</commit_message>
<xml_diff>
--- a/_present/Krypto-Learning-Hub.pptx
+++ b/_present/Krypto-Learning-Hub.pptx
@@ -1948,7 +1948,7 @@
             <a:r>
               <a:rPr lang="en-US" sz="1400" spc="300" kern="0" dirty="0">
                 <a:solidFill>
-                  <a:srgbClr val="0D9488"/>
+                  <a:srgbClr val="2DD4BF"/>
                 </a:solidFill>
                 <a:latin typeface="Consolas" pitchFamily="34" charset="0"/>
                 <a:ea typeface="Consolas" pitchFamily="34" charset="-122"/>
@@ -2026,7 +2026,7 @@
             <a:r>
               <a:rPr lang="en-US" sz="2000" dirty="0">
                 <a:solidFill>
-                  <a:srgbClr val="94A6C2"/>
+                  <a:srgbClr val="9FB0CC"/>
                 </a:solidFill>
                 <a:latin typeface="Calibri" pitchFamily="34" charset="0"/>
                 <a:ea typeface="Calibri" pitchFamily="34" charset="-122"/>
@@ -2055,7 +2055,7 @@
           <a:noFill/>
           <a:ln w="25400">
             <a:solidFill>
-              <a:srgbClr val="0D9488"/>
+              <a:srgbClr val="2DD4BF"/>
             </a:solidFill>
             <a:prstDash val="solid"/>
           </a:ln>
@@ -2111,7 +2111,7 @@
             <a:r>
               <a:rPr lang="en-US" sz="1400" dirty="0">
                 <a:solidFill>
-                  <a:srgbClr val="0D9488"/>
+                  <a:srgbClr val="2DD4BF"/>
                 </a:solidFill>
                 <a:latin typeface="Consolas" pitchFamily="34" charset="0"/>
                 <a:ea typeface="Consolas" pitchFamily="34" charset="-122"/>
@@ -2137,7 +2137,7 @@
     <p:bg>
       <p:bgPr>
         <a:solidFill>
-          <a:srgbClr val="F7FAFC"/>
+          <a:srgbClr val="0B1220"/>
         </a:solidFill>
       </p:bgPr>
     </p:bg>
@@ -2182,7 +2182,7 @@
             <a:r>
               <a:rPr lang="en-US" sz="1250" b="1" spc="200" kern="0" dirty="0">
                 <a:solidFill>
-                  <a:srgbClr val="0D9488"/>
+                  <a:srgbClr val="2DD4BF"/>
                 </a:solidFill>
                 <a:latin typeface="Consolas" pitchFamily="34" charset="0"/>
                 <a:ea typeface="Consolas" pitchFamily="34" charset="-122"/>
@@ -2196,7 +2196,7 @@
             <a:r>
               <a:rPr lang="en-US" sz="1250" spc="200" kern="0" dirty="0">
                 <a:solidFill>
-                  <a:srgbClr val="566377"/>
+                  <a:srgbClr val="9FB0CC"/>
                 </a:solidFill>
                 <a:latin typeface="Consolas" pitchFamily="34" charset="0"/>
                 <a:ea typeface="Consolas" pitchFamily="34" charset="-122"/>
@@ -2235,7 +2235,7 @@
             <a:r>
               <a:rPr lang="en-US" sz="3100" b="1" dirty="0">
                 <a:solidFill>
-                  <a:srgbClr val="0F172A"/>
+                  <a:srgbClr val="EAF1FB"/>
                 </a:solidFill>
                 <a:latin typeface="Trebuchet MS" pitchFamily="34" charset="0"/>
                 <a:ea typeface="Trebuchet MS" pitchFamily="34" charset="-122"/>
@@ -2262,18 +2262,18 @@
             <a:avLst/>
           </a:prstGeom>
           <a:solidFill>
-            <a:srgbClr val="FFFFFF"/>
+            <a:srgbClr val="141F38"/>
           </a:solidFill>
           <a:ln w="12700">
             <a:solidFill>
-              <a:srgbClr val="E3E9F1"/>
+              <a:srgbClr val="2A3A59"/>
             </a:solidFill>
             <a:prstDash val="solid"/>
           </a:ln>
           <a:effectLst>
-            <a:outerShdw sx="100000" sy="100000" kx="0" ky="0" algn="bl" rotWithShape="0" blurRad="114300" dist="38100" dir="5400000">
-              <a:srgbClr val="0F172A">
-                <a:alpha val="10000"/>
+            <a:outerShdw sx="100000" sy="100000" kx="0" ky="0" algn="bl" rotWithShape="0" blurRad="127000" dist="38100" dir="5400000">
+              <a:srgbClr val="000000">
+                <a:alpha val="35000"/>
               </a:srgbClr>
             </a:outerShdw>
           </a:effectLst>
@@ -2294,7 +2294,7 @@
             <a:avLst/>
           </a:prstGeom>
           <a:solidFill>
-            <a:srgbClr val="2563EB"/>
+            <a:srgbClr val="3B82F6"/>
           </a:solidFill>
           <a:ln/>
         </p:spPr>
@@ -2314,7 +2314,7 @@
             <a:avLst/>
           </a:prstGeom>
           <a:solidFill>
-            <a:srgbClr val="2563EB"/>
+            <a:srgbClr val="3B82F6"/>
           </a:solidFill>
           <a:ln/>
         </p:spPr>
@@ -2385,7 +2385,7 @@
             <a:r>
               <a:rPr lang="en-US" sz="1900" b="1" dirty="0">
                 <a:solidFill>
-                  <a:srgbClr val="0F172A"/>
+                  <a:srgbClr val="EAF1FB"/>
                 </a:solidFill>
                 <a:latin typeface="Trebuchet MS" pitchFamily="34" charset="0"/>
                 <a:ea typeface="Trebuchet MS" pitchFamily="34" charset="-122"/>
@@ -2427,7 +2427,7 @@
             <a:r>
               <a:rPr lang="en-US" sz="1450" dirty="0">
                 <a:solidFill>
-                  <a:srgbClr val="566377"/>
+                  <a:srgbClr val="9FB0CC"/>
                 </a:solidFill>
                 <a:latin typeface="Calibri" pitchFamily="34" charset="0"/>
                 <a:ea typeface="Calibri" pitchFamily="34" charset="-122"/>
@@ -2454,18 +2454,18 @@
             <a:avLst/>
           </a:prstGeom>
           <a:solidFill>
-            <a:srgbClr val="FFFFFF"/>
+            <a:srgbClr val="141F38"/>
           </a:solidFill>
           <a:ln w="12700">
             <a:solidFill>
-              <a:srgbClr val="E3E9F1"/>
+              <a:srgbClr val="2A3A59"/>
             </a:solidFill>
             <a:prstDash val="solid"/>
           </a:ln>
           <a:effectLst>
-            <a:outerShdw sx="100000" sy="100000" kx="0" ky="0" algn="bl" rotWithShape="0" blurRad="114300" dist="38100" dir="5400000">
-              <a:srgbClr val="0F172A">
-                <a:alpha val="10000"/>
+            <a:outerShdw sx="100000" sy="100000" kx="0" ky="0" algn="bl" rotWithShape="0" blurRad="127000" dist="38100" dir="5400000">
+              <a:srgbClr val="000000">
+                <a:alpha val="35000"/>
               </a:srgbClr>
             </a:outerShdw>
           </a:effectLst>
@@ -2486,7 +2486,7 @@
             <a:avLst/>
           </a:prstGeom>
           <a:solidFill>
-            <a:srgbClr val="059669"/>
+            <a:srgbClr val="10B981"/>
           </a:solidFill>
           <a:ln/>
         </p:spPr>
@@ -2506,7 +2506,7 @@
             <a:avLst/>
           </a:prstGeom>
           <a:solidFill>
-            <a:srgbClr val="059669"/>
+            <a:srgbClr val="10B981"/>
           </a:solidFill>
           <a:ln/>
         </p:spPr>
@@ -2577,7 +2577,7 @@
             <a:r>
               <a:rPr lang="en-US" sz="1900" b="1" dirty="0">
                 <a:solidFill>
-                  <a:srgbClr val="0F172A"/>
+                  <a:srgbClr val="EAF1FB"/>
                 </a:solidFill>
                 <a:latin typeface="Trebuchet MS" pitchFamily="34" charset="0"/>
                 <a:ea typeface="Trebuchet MS" pitchFamily="34" charset="-122"/>
@@ -2619,7 +2619,7 @@
             <a:r>
               <a:rPr lang="en-US" sz="1450" dirty="0">
                 <a:solidFill>
-                  <a:srgbClr val="566377"/>
+                  <a:srgbClr val="9FB0CC"/>
                 </a:solidFill>
                 <a:latin typeface="Calibri" pitchFamily="34" charset="0"/>
                 <a:ea typeface="Calibri" pitchFamily="34" charset="-122"/>
@@ -2646,18 +2646,18 @@
             <a:avLst/>
           </a:prstGeom>
           <a:solidFill>
-            <a:srgbClr val="FFFFFF"/>
+            <a:srgbClr val="141F38"/>
           </a:solidFill>
           <a:ln w="12700">
             <a:solidFill>
-              <a:srgbClr val="E3E9F1"/>
+              <a:srgbClr val="2A3A59"/>
             </a:solidFill>
             <a:prstDash val="solid"/>
           </a:ln>
           <a:effectLst>
-            <a:outerShdw sx="100000" sy="100000" kx="0" ky="0" algn="bl" rotWithShape="0" blurRad="114300" dist="38100" dir="5400000">
-              <a:srgbClr val="0F172A">
-                <a:alpha val="10000"/>
+            <a:outerShdw sx="100000" sy="100000" kx="0" ky="0" algn="bl" rotWithShape="0" blurRad="127000" dist="38100" dir="5400000">
+              <a:srgbClr val="000000">
+                <a:alpha val="35000"/>
               </a:srgbClr>
             </a:outerShdw>
           </a:effectLst>
@@ -2678,7 +2678,7 @@
             <a:avLst/>
           </a:prstGeom>
           <a:solidFill>
-            <a:srgbClr val="7C3AED"/>
+            <a:srgbClr val="8B5CF6"/>
           </a:solidFill>
           <a:ln/>
         </p:spPr>
@@ -2698,7 +2698,7 @@
             <a:avLst/>
           </a:prstGeom>
           <a:solidFill>
-            <a:srgbClr val="7C3AED"/>
+            <a:srgbClr val="8B5CF6"/>
           </a:solidFill>
           <a:ln/>
         </p:spPr>
@@ -2769,7 +2769,7 @@
             <a:r>
               <a:rPr lang="en-US" sz="1900" b="1" dirty="0">
                 <a:solidFill>
-                  <a:srgbClr val="0F172A"/>
+                  <a:srgbClr val="EAF1FB"/>
                 </a:solidFill>
                 <a:latin typeface="Trebuchet MS" pitchFamily="34" charset="0"/>
                 <a:ea typeface="Trebuchet MS" pitchFamily="34" charset="-122"/>
@@ -2811,7 +2811,7 @@
             <a:r>
               <a:rPr lang="en-US" sz="1450" dirty="0">
                 <a:solidFill>
-                  <a:srgbClr val="566377"/>
+                  <a:srgbClr val="9FB0CC"/>
                 </a:solidFill>
                 <a:latin typeface="Calibri" pitchFamily="34" charset="0"/>
                 <a:ea typeface="Calibri" pitchFamily="34" charset="-122"/>
@@ -3038,7 +3038,7 @@
             <a:r>
               <a:rPr lang="en-US" sz="1500" spc="400" kern="0" dirty="0">
                 <a:solidFill>
-                  <a:srgbClr val="0D9488"/>
+                  <a:srgbClr val="2DD4BF"/>
                 </a:solidFill>
                 <a:latin typeface="Consolas" pitchFamily="34" charset="0"/>
                 <a:ea typeface="Consolas" pitchFamily="34" charset="-122"/>
@@ -3106,7 +3106,7 @@
           <a:noFill/>
           <a:ln w="25400">
             <a:solidFill>
-              <a:srgbClr val="0D9488"/>
+              <a:srgbClr val="2DD4BF"/>
             </a:solidFill>
             <a:prstDash val="solid"/>
           </a:ln>
@@ -3139,7 +3139,7 @@
             <a:r>
               <a:rPr lang="en-US" sz="1700" dirty="0">
                 <a:solidFill>
-                  <a:srgbClr val="94A6C2"/>
+                  <a:srgbClr val="9FB0CC"/>
                 </a:solidFill>
                 <a:latin typeface="Calibri" pitchFamily="34" charset="0"/>
                 <a:ea typeface="Calibri" pitchFamily="34" charset="-122"/>
@@ -3153,7 +3153,7 @@
             <a:r>
               <a:rPr lang="en-US" sz="1700" b="1" dirty="0">
                 <a:solidFill>
-                  <a:srgbClr val="0D9488"/>
+                  <a:srgbClr val="2DD4BF"/>
                 </a:solidFill>
                 <a:latin typeface="Consolas" pitchFamily="34" charset="0"/>
                 <a:ea typeface="Consolas" pitchFamily="34" charset="-122"/>
@@ -3192,7 +3192,7 @@
             <a:r>
               <a:rPr lang="en-US" sz="1500" dirty="0">
                 <a:solidFill>
-                  <a:srgbClr val="94A6C2"/>
+                  <a:srgbClr val="9FB0CC"/>
                 </a:solidFill>
                 <a:latin typeface="Calibri" pitchFamily="34" charset="0"/>
                 <a:ea typeface="Calibri" pitchFamily="34" charset="-122"/>
@@ -3218,7 +3218,7 @@
     <p:bg>
       <p:bgPr>
         <a:solidFill>
-          <a:srgbClr val="F7FAFC"/>
+          <a:srgbClr val="0B1220"/>
         </a:solidFill>
       </p:bgPr>
     </p:bg>
@@ -3263,7 +3263,7 @@
             <a:r>
               <a:rPr lang="en-US" sz="1250" b="1" spc="200" kern="0" dirty="0">
                 <a:solidFill>
-                  <a:srgbClr val="0D9488"/>
+                  <a:srgbClr val="2DD4BF"/>
                 </a:solidFill>
                 <a:latin typeface="Consolas" pitchFamily="34" charset="0"/>
                 <a:ea typeface="Consolas" pitchFamily="34" charset="-122"/>
@@ -3277,7 +3277,7 @@
             <a:r>
               <a:rPr lang="en-US" sz="1250" spc="200" kern="0" dirty="0">
                 <a:solidFill>
-                  <a:srgbClr val="566377"/>
+                  <a:srgbClr val="9FB0CC"/>
                 </a:solidFill>
                 <a:latin typeface="Consolas" pitchFamily="34" charset="0"/>
                 <a:ea typeface="Consolas" pitchFamily="34" charset="-122"/>
@@ -3316,7 +3316,7 @@
             <a:r>
               <a:rPr lang="en-US" sz="3100" b="1" dirty="0">
                 <a:solidFill>
-                  <a:srgbClr val="0F172A"/>
+                  <a:srgbClr val="EAF1FB"/>
                 </a:solidFill>
                 <a:latin typeface="Trebuchet MS" pitchFamily="34" charset="0"/>
                 <a:ea typeface="Trebuchet MS" pitchFamily="34" charset="-122"/>
@@ -3343,18 +3343,18 @@
             <a:avLst/>
           </a:prstGeom>
           <a:solidFill>
-            <a:srgbClr val="FFFFFF"/>
+            <a:srgbClr val="141F38"/>
           </a:solidFill>
           <a:ln w="12700">
             <a:solidFill>
-              <a:srgbClr val="E3E9F1"/>
+              <a:srgbClr val="2A3A59"/>
             </a:solidFill>
             <a:prstDash val="solid"/>
           </a:ln>
           <a:effectLst>
-            <a:outerShdw sx="100000" sy="100000" kx="0" ky="0" algn="bl" rotWithShape="0" blurRad="114300" dist="38100" dir="5400000">
-              <a:srgbClr val="0F172A">
-                <a:alpha val="10000"/>
+            <a:outerShdw sx="100000" sy="100000" kx="0" ky="0" algn="bl" rotWithShape="0" blurRad="127000" dist="38100" dir="5400000">
+              <a:srgbClr val="000000">
+                <a:alpha val="35000"/>
               </a:srgbClr>
             </a:outerShdw>
           </a:effectLst>
@@ -3375,7 +3375,7 @@
             <a:avLst/>
           </a:prstGeom>
           <a:solidFill>
-            <a:srgbClr val="7C3AED"/>
+            <a:srgbClr val="8B5CF6"/>
           </a:solidFill>
           <a:ln/>
         </p:spPr>
@@ -3407,7 +3407,7 @@
             <a:r>
               <a:rPr lang="en-US" sz="1250" b="1" spc="200" kern="0" dirty="0">
                 <a:solidFill>
-                  <a:srgbClr val="7C3AED"/>
+                  <a:srgbClr val="8B5CF6"/>
                 </a:solidFill>
                 <a:latin typeface="Consolas" pitchFamily="34" charset="0"/>
                 <a:ea typeface="Consolas" pitchFamily="34" charset="-122"/>
@@ -3446,7 +3446,7 @@
             <a:r>
               <a:rPr lang="en-US" sz="2100" b="1" i="1" dirty="0">
                 <a:solidFill>
-                  <a:srgbClr val="0F172A"/>
+                  <a:srgbClr val="EAF1FB"/>
                 </a:solidFill>
                 <a:latin typeface="Trebuchet MS" pitchFamily="34" charset="0"/>
                 <a:ea typeface="Trebuchet MS" pitchFamily="34" charset="-122"/>
@@ -3492,7 +3492,7 @@
             <a:r>
               <a:rPr lang="en-US" sz="1500" dirty="0">
                 <a:solidFill>
-                  <a:srgbClr val="566377"/>
+                  <a:srgbClr val="9FB0CC"/>
                 </a:solidFill>
                 <a:latin typeface="Calibri" pitchFamily="34" charset="0"/>
                 <a:ea typeface="Calibri" pitchFamily="34" charset="-122"/>
@@ -3516,7 +3516,7 @@
             <a:r>
               <a:rPr lang="en-US" sz="1500" dirty="0">
                 <a:solidFill>
-                  <a:srgbClr val="566377"/>
+                  <a:srgbClr val="9FB0CC"/>
                 </a:solidFill>
                 <a:latin typeface="Calibri" pitchFamily="34" charset="0"/>
                 <a:ea typeface="Calibri" pitchFamily="34" charset="-122"/>
@@ -3540,7 +3540,7 @@
             <a:r>
               <a:rPr lang="en-US" sz="1500" dirty="0">
                 <a:solidFill>
-                  <a:srgbClr val="566377"/>
+                  <a:srgbClr val="9FB0CC"/>
                 </a:solidFill>
                 <a:latin typeface="Calibri" pitchFamily="34" charset="0"/>
                 <a:ea typeface="Calibri" pitchFamily="34" charset="-122"/>
@@ -3579,7 +3579,7 @@
             <a:r>
               <a:rPr lang="en-US" sz="1250" b="1" spc="200" kern="0" dirty="0">
                 <a:solidFill>
-                  <a:srgbClr val="0D9488"/>
+                  <a:srgbClr val="2DD4BF"/>
                 </a:solidFill>
                 <a:latin typeface="Consolas" pitchFamily="34" charset="0"/>
                 <a:ea typeface="Consolas" pitchFamily="34" charset="-122"/>
@@ -3606,18 +3606,18 @@
             <a:avLst/>
           </a:prstGeom>
           <a:solidFill>
-            <a:srgbClr val="FFFFFF"/>
+            <a:srgbClr val="141F38"/>
           </a:solidFill>
           <a:ln w="12700">
             <a:solidFill>
-              <a:srgbClr val="E3E9F1"/>
+              <a:srgbClr val="2A3A59"/>
             </a:solidFill>
             <a:prstDash val="solid"/>
           </a:ln>
           <a:effectLst>
-            <a:outerShdw sx="100000" sy="100000" kx="0" ky="0" algn="bl" rotWithShape="0" blurRad="114300" dist="38100" dir="5400000">
-              <a:srgbClr val="0F172A">
-                <a:alpha val="10000"/>
+            <a:outerShdw sx="100000" sy="100000" kx="0" ky="0" algn="bl" rotWithShape="0" blurRad="127000" dist="38100" dir="5400000">
+              <a:srgbClr val="000000">
+                <a:alpha val="35000"/>
               </a:srgbClr>
             </a:outerShdw>
           </a:effectLst>
@@ -3638,7 +3638,7 @@
             <a:avLst/>
           </a:prstGeom>
           <a:solidFill>
-            <a:srgbClr val="2563EB"/>
+            <a:srgbClr val="3B82F6"/>
           </a:solidFill>
           <a:ln/>
         </p:spPr>
@@ -3670,7 +3670,7 @@
             <a:r>
               <a:rPr lang="en-US" sz="4400" b="1" dirty="0">
                 <a:solidFill>
-                  <a:srgbClr val="2563EB"/>
+                  <a:srgbClr val="3B82F6"/>
                 </a:solidFill>
                 <a:latin typeface="Trebuchet MS" pitchFamily="34" charset="0"/>
                 <a:ea typeface="Trebuchet MS" pitchFamily="34" charset="-122"/>
@@ -3709,7 +3709,7 @@
             <a:r>
               <a:rPr lang="en-US" sz="1350" dirty="0">
                 <a:solidFill>
-                  <a:srgbClr val="566377"/>
+                  <a:srgbClr val="9FB0CC"/>
                 </a:solidFill>
                 <a:latin typeface="Calibri" pitchFamily="34" charset="0"/>
                 <a:ea typeface="Calibri" pitchFamily="34" charset="-122"/>
@@ -3736,18 +3736,18 @@
             <a:avLst/>
           </a:prstGeom>
           <a:solidFill>
-            <a:srgbClr val="FFFFFF"/>
+            <a:srgbClr val="141F38"/>
           </a:solidFill>
           <a:ln w="12700">
             <a:solidFill>
-              <a:srgbClr val="E3E9F1"/>
+              <a:srgbClr val="2A3A59"/>
             </a:solidFill>
             <a:prstDash val="solid"/>
           </a:ln>
           <a:effectLst>
-            <a:outerShdw sx="100000" sy="100000" kx="0" ky="0" algn="bl" rotWithShape="0" blurRad="114300" dist="38100" dir="5400000">
-              <a:srgbClr val="0F172A">
-                <a:alpha val="10000"/>
+            <a:outerShdw sx="100000" sy="100000" kx="0" ky="0" algn="bl" rotWithShape="0" blurRad="127000" dist="38100" dir="5400000">
+              <a:srgbClr val="000000">
+                <a:alpha val="35000"/>
               </a:srgbClr>
             </a:outerShdw>
           </a:effectLst>
@@ -3768,7 +3768,7 @@
             <a:avLst/>
           </a:prstGeom>
           <a:solidFill>
-            <a:srgbClr val="059669"/>
+            <a:srgbClr val="10B981"/>
           </a:solidFill>
           <a:ln/>
         </p:spPr>
@@ -3800,7 +3800,7 @@
             <a:r>
               <a:rPr lang="en-US" sz="4400" b="1" dirty="0">
                 <a:solidFill>
-                  <a:srgbClr val="059669"/>
+                  <a:srgbClr val="10B981"/>
                 </a:solidFill>
                 <a:latin typeface="Trebuchet MS" pitchFamily="34" charset="0"/>
                 <a:ea typeface="Trebuchet MS" pitchFamily="34" charset="-122"/>
@@ -3839,7 +3839,7 @@
             <a:r>
               <a:rPr lang="en-US" sz="1350" dirty="0">
                 <a:solidFill>
-                  <a:srgbClr val="566377"/>
+                  <a:srgbClr val="9FB0CC"/>
                 </a:solidFill>
                 <a:latin typeface="Calibri" pitchFamily="34" charset="0"/>
                 <a:ea typeface="Calibri" pitchFamily="34" charset="-122"/>
@@ -3866,18 +3866,18 @@
             <a:avLst/>
           </a:prstGeom>
           <a:solidFill>
-            <a:srgbClr val="FFFFFF"/>
+            <a:srgbClr val="141F38"/>
           </a:solidFill>
           <a:ln w="12700">
             <a:solidFill>
-              <a:srgbClr val="E3E9F1"/>
+              <a:srgbClr val="2A3A59"/>
             </a:solidFill>
             <a:prstDash val="solid"/>
           </a:ln>
           <a:effectLst>
-            <a:outerShdw sx="100000" sy="100000" kx="0" ky="0" algn="bl" rotWithShape="0" blurRad="114300" dist="38100" dir="5400000">
-              <a:srgbClr val="0F172A">
-                <a:alpha val="10000"/>
+            <a:outerShdw sx="100000" sy="100000" kx="0" ky="0" algn="bl" rotWithShape="0" blurRad="127000" dist="38100" dir="5400000">
+              <a:srgbClr val="000000">
+                <a:alpha val="35000"/>
               </a:srgbClr>
             </a:outerShdw>
           </a:effectLst>
@@ -3898,7 +3898,7 @@
             <a:avLst/>
           </a:prstGeom>
           <a:solidFill>
-            <a:srgbClr val="E11D48"/>
+            <a:srgbClr val="F43F5E"/>
           </a:solidFill>
           <a:ln/>
         </p:spPr>
@@ -3930,7 +3930,7 @@
             <a:r>
               <a:rPr lang="en-US" sz="4400" b="1" dirty="0">
                 <a:solidFill>
-                  <a:srgbClr val="E11D48"/>
+                  <a:srgbClr val="F43F5E"/>
                 </a:solidFill>
                 <a:latin typeface="Trebuchet MS" pitchFamily="34" charset="0"/>
                 <a:ea typeface="Trebuchet MS" pitchFamily="34" charset="-122"/>
@@ -3969,7 +3969,7 @@
             <a:r>
               <a:rPr lang="en-US" sz="1350" dirty="0">
                 <a:solidFill>
-                  <a:srgbClr val="566377"/>
+                  <a:srgbClr val="9FB0CC"/>
                 </a:solidFill>
                 <a:latin typeface="Calibri" pitchFamily="34" charset="0"/>
                 <a:ea typeface="Calibri" pitchFamily="34" charset="-122"/>
@@ -3996,18 +3996,18 @@
             <a:avLst/>
           </a:prstGeom>
           <a:solidFill>
-            <a:srgbClr val="FFFFFF"/>
+            <a:srgbClr val="141F38"/>
           </a:solidFill>
           <a:ln w="12700">
             <a:solidFill>
-              <a:srgbClr val="E3E9F1"/>
+              <a:srgbClr val="2A3A59"/>
             </a:solidFill>
             <a:prstDash val="solid"/>
           </a:ln>
           <a:effectLst>
-            <a:outerShdw sx="100000" sy="100000" kx="0" ky="0" algn="bl" rotWithShape="0" blurRad="114300" dist="38100" dir="5400000">
-              <a:srgbClr val="0F172A">
-                <a:alpha val="10000"/>
+            <a:outerShdw sx="100000" sy="100000" kx="0" ky="0" algn="bl" rotWithShape="0" blurRad="127000" dist="38100" dir="5400000">
+              <a:srgbClr val="000000">
+                <a:alpha val="35000"/>
               </a:srgbClr>
             </a:outerShdw>
           </a:effectLst>
@@ -4028,7 +4028,7 @@
             <a:avLst/>
           </a:prstGeom>
           <a:solidFill>
-            <a:srgbClr val="D97706"/>
+            <a:srgbClr val="F59E0B"/>
           </a:solidFill>
           <a:ln/>
         </p:spPr>
@@ -4060,7 +4060,7 @@
             <a:r>
               <a:rPr lang="en-US" sz="4400" b="1" dirty="0">
                 <a:solidFill>
-                  <a:srgbClr val="D97706"/>
+                  <a:srgbClr val="F59E0B"/>
                 </a:solidFill>
                 <a:latin typeface="Trebuchet MS" pitchFamily="34" charset="0"/>
                 <a:ea typeface="Trebuchet MS" pitchFamily="34" charset="-122"/>
@@ -4099,7 +4099,7 @@
             <a:r>
               <a:rPr lang="en-US" sz="1350" dirty="0">
                 <a:solidFill>
-                  <a:srgbClr val="566377"/>
+                  <a:srgbClr val="9FB0CC"/>
                 </a:solidFill>
                 <a:latin typeface="Calibri" pitchFamily="34" charset="0"/>
                 <a:ea typeface="Calibri" pitchFamily="34" charset="-122"/>
@@ -4125,7 +4125,7 @@
     <p:bg>
       <p:bgPr>
         <a:solidFill>
-          <a:srgbClr val="F7FAFC"/>
+          <a:srgbClr val="0B1220"/>
         </a:solidFill>
       </p:bgPr>
     </p:bg>
@@ -4170,7 +4170,7 @@
             <a:r>
               <a:rPr lang="en-US" sz="1250" b="1" spc="200" kern="0" dirty="0">
                 <a:solidFill>
-                  <a:srgbClr val="0D9488"/>
+                  <a:srgbClr val="2DD4BF"/>
                 </a:solidFill>
                 <a:latin typeface="Consolas" pitchFamily="34" charset="0"/>
                 <a:ea typeface="Consolas" pitchFamily="34" charset="-122"/>
@@ -4184,7 +4184,7 @@
             <a:r>
               <a:rPr lang="en-US" sz="1250" spc="200" kern="0" dirty="0">
                 <a:solidFill>
-                  <a:srgbClr val="566377"/>
+                  <a:srgbClr val="9FB0CC"/>
                 </a:solidFill>
                 <a:latin typeface="Consolas" pitchFamily="34" charset="0"/>
                 <a:ea typeface="Consolas" pitchFamily="34" charset="-122"/>
@@ -4223,7 +4223,7 @@
             <a:r>
               <a:rPr lang="en-US" sz="3100" b="1" dirty="0">
                 <a:solidFill>
-                  <a:srgbClr val="0F172A"/>
+                  <a:srgbClr val="EAF1FB"/>
                 </a:solidFill>
                 <a:latin typeface="Trebuchet MS" pitchFamily="34" charset="0"/>
                 <a:ea typeface="Trebuchet MS" pitchFamily="34" charset="-122"/>
@@ -4250,18 +4250,18 @@
             <a:avLst/>
           </a:prstGeom>
           <a:solidFill>
-            <a:srgbClr val="FFFFFF"/>
+            <a:srgbClr val="141F38"/>
           </a:solidFill>
           <a:ln w="12700">
             <a:solidFill>
-              <a:srgbClr val="E3E9F1"/>
+              <a:srgbClr val="2A3A59"/>
             </a:solidFill>
             <a:prstDash val="solid"/>
           </a:ln>
           <a:effectLst>
-            <a:outerShdw sx="100000" sy="100000" kx="0" ky="0" algn="bl" rotWithShape="0" blurRad="114300" dist="38100" dir="5400000">
-              <a:srgbClr val="0F172A">
-                <a:alpha val="10000"/>
+            <a:outerShdw sx="100000" sy="100000" kx="0" ky="0" algn="bl" rotWithShape="0" blurRad="127000" dist="38100" dir="5400000">
+              <a:srgbClr val="000000">
+                <a:alpha val="35000"/>
               </a:srgbClr>
             </a:outerShdw>
           </a:effectLst>
@@ -4282,7 +4282,7 @@
             <a:avLst/>
           </a:prstGeom>
           <a:solidFill>
-            <a:srgbClr val="2563EB"/>
+            <a:srgbClr val="3B82F6"/>
           </a:solidFill>
           <a:ln/>
         </p:spPr>
@@ -4302,7 +4302,7 @@
             <a:avLst/>
           </a:prstGeom>
           <a:solidFill>
-            <a:srgbClr val="2563EB"/>
+            <a:srgbClr val="3B82F6"/>
           </a:solidFill>
           <a:ln/>
         </p:spPr>
@@ -4373,7 +4373,7 @@
             <a:r>
               <a:rPr lang="en-US" sz="2100" b="1" dirty="0">
                 <a:solidFill>
-                  <a:srgbClr val="0F172A"/>
+                  <a:srgbClr val="EAF1FB"/>
                 </a:solidFill>
                 <a:latin typeface="Trebuchet MS" pitchFamily="34" charset="0"/>
                 <a:ea typeface="Trebuchet MS" pitchFamily="34" charset="-122"/>
@@ -4412,7 +4412,7 @@
             <a:r>
               <a:rPr lang="en-US" sz="1650" i="1" dirty="0">
                 <a:solidFill>
-                  <a:srgbClr val="0F172A"/>
+                  <a:srgbClr val="EAF1FB"/>
                 </a:solidFill>
                 <a:latin typeface="Calibri" pitchFamily="34" charset="0"/>
                 <a:ea typeface="Calibri" pitchFamily="34" charset="-122"/>
@@ -4441,7 +4441,7 @@
           <a:noFill/>
           <a:ln w="12700">
             <a:solidFill>
-              <a:srgbClr val="E3E9F1"/>
+              <a:srgbClr val="2A3A59"/>
             </a:solidFill>
             <a:prstDash val="solid"/>
           </a:ln>
@@ -4474,7 +4474,7 @@
             <a:r>
               <a:rPr lang="en-US" sz="1150" b="1" spc="100" kern="0" dirty="0">
                 <a:solidFill>
-                  <a:srgbClr val="2563EB"/>
+                  <a:srgbClr val="3B82F6"/>
                 </a:solidFill>
                 <a:latin typeface="Consolas" pitchFamily="34" charset="0"/>
                 <a:ea typeface="Consolas" pitchFamily="34" charset="-122"/>
@@ -4516,7 +4516,7 @@
             <a:r>
               <a:rPr lang="en-US" sz="1500" dirty="0">
                 <a:solidFill>
-                  <a:srgbClr val="566377"/>
+                  <a:srgbClr val="9FB0CC"/>
                 </a:solidFill>
                 <a:latin typeface="Calibri" pitchFamily="34" charset="0"/>
                 <a:ea typeface="Calibri" pitchFamily="34" charset="-122"/>
@@ -4536,7 +4536,7 @@
             <a:r>
               <a:rPr lang="en-US" sz="1500" dirty="0">
                 <a:solidFill>
-                  <a:srgbClr val="566377"/>
+                  <a:srgbClr val="9FB0CC"/>
                 </a:solidFill>
                 <a:latin typeface="Calibri" pitchFamily="34" charset="0"/>
                 <a:ea typeface="Calibri" pitchFamily="34" charset="-122"/>
@@ -4563,18 +4563,18 @@
             <a:avLst/>
           </a:prstGeom>
           <a:solidFill>
-            <a:srgbClr val="FFFFFF"/>
+            <a:srgbClr val="141F38"/>
           </a:solidFill>
           <a:ln w="12700">
             <a:solidFill>
-              <a:srgbClr val="E3E9F1"/>
+              <a:srgbClr val="2A3A59"/>
             </a:solidFill>
             <a:prstDash val="solid"/>
           </a:ln>
           <a:effectLst>
-            <a:outerShdw sx="100000" sy="100000" kx="0" ky="0" algn="bl" rotWithShape="0" blurRad="114300" dist="38100" dir="5400000">
-              <a:srgbClr val="0F172A">
-                <a:alpha val="10000"/>
+            <a:outerShdw sx="100000" sy="100000" kx="0" ky="0" algn="bl" rotWithShape="0" blurRad="127000" dist="38100" dir="5400000">
+              <a:srgbClr val="000000">
+                <a:alpha val="35000"/>
               </a:srgbClr>
             </a:outerShdw>
           </a:effectLst>
@@ -4595,7 +4595,7 @@
             <a:avLst/>
           </a:prstGeom>
           <a:solidFill>
-            <a:srgbClr val="059669"/>
+            <a:srgbClr val="10B981"/>
           </a:solidFill>
           <a:ln/>
         </p:spPr>
@@ -4615,7 +4615,7 @@
             <a:avLst/>
           </a:prstGeom>
           <a:solidFill>
-            <a:srgbClr val="059669"/>
+            <a:srgbClr val="10B981"/>
           </a:solidFill>
           <a:ln/>
         </p:spPr>
@@ -4686,7 +4686,7 @@
             <a:r>
               <a:rPr lang="en-US" sz="2100" b="1" dirty="0">
                 <a:solidFill>
-                  <a:srgbClr val="0F172A"/>
+                  <a:srgbClr val="EAF1FB"/>
                 </a:solidFill>
                 <a:latin typeface="Trebuchet MS" pitchFamily="34" charset="0"/>
                 <a:ea typeface="Trebuchet MS" pitchFamily="34" charset="-122"/>
@@ -4725,7 +4725,7 @@
             <a:r>
               <a:rPr lang="en-US" sz="1650" i="1" dirty="0">
                 <a:solidFill>
-                  <a:srgbClr val="0F172A"/>
+                  <a:srgbClr val="EAF1FB"/>
                 </a:solidFill>
                 <a:latin typeface="Calibri" pitchFamily="34" charset="0"/>
                 <a:ea typeface="Calibri" pitchFamily="34" charset="-122"/>
@@ -4754,7 +4754,7 @@
           <a:noFill/>
           <a:ln w="12700">
             <a:solidFill>
-              <a:srgbClr val="E3E9F1"/>
+              <a:srgbClr val="2A3A59"/>
             </a:solidFill>
             <a:prstDash val="solid"/>
           </a:ln>
@@ -4787,7 +4787,7 @@
             <a:r>
               <a:rPr lang="en-US" sz="1150" b="1" spc="100" kern="0" dirty="0">
                 <a:solidFill>
-                  <a:srgbClr val="059669"/>
+                  <a:srgbClr val="10B981"/>
                 </a:solidFill>
                 <a:latin typeface="Consolas" pitchFamily="34" charset="0"/>
                 <a:ea typeface="Consolas" pitchFamily="34" charset="-122"/>
@@ -4829,7 +4829,7 @@
             <a:r>
               <a:rPr lang="en-US" sz="1500" dirty="0">
                 <a:solidFill>
-                  <a:srgbClr val="566377"/>
+                  <a:srgbClr val="9FB0CC"/>
                 </a:solidFill>
                 <a:latin typeface="Calibri" pitchFamily="34" charset="0"/>
                 <a:ea typeface="Calibri" pitchFamily="34" charset="-122"/>
@@ -4849,7 +4849,7 @@
             <a:r>
               <a:rPr lang="en-US" sz="1500" dirty="0">
                 <a:solidFill>
-                  <a:srgbClr val="566377"/>
+                  <a:srgbClr val="9FB0CC"/>
                 </a:solidFill>
                 <a:latin typeface="Calibri" pitchFamily="34" charset="0"/>
                 <a:ea typeface="Calibri" pitchFamily="34" charset="-122"/>
@@ -4876,18 +4876,18 @@
             <a:avLst/>
           </a:prstGeom>
           <a:solidFill>
-            <a:srgbClr val="FFFFFF"/>
+            <a:srgbClr val="141F38"/>
           </a:solidFill>
           <a:ln w="12700">
             <a:solidFill>
-              <a:srgbClr val="E3E9F1"/>
+              <a:srgbClr val="2A3A59"/>
             </a:solidFill>
             <a:prstDash val="solid"/>
           </a:ln>
           <a:effectLst>
-            <a:outerShdw sx="100000" sy="100000" kx="0" ky="0" algn="bl" rotWithShape="0" blurRad="114300" dist="38100" dir="5400000">
-              <a:srgbClr val="0F172A">
-                <a:alpha val="10000"/>
+            <a:outerShdw sx="100000" sy="100000" kx="0" ky="0" algn="bl" rotWithShape="0" blurRad="127000" dist="38100" dir="5400000">
+              <a:srgbClr val="000000">
+                <a:alpha val="35000"/>
               </a:srgbClr>
             </a:outerShdw>
           </a:effectLst>
@@ -4908,7 +4908,7 @@
             <a:avLst/>
           </a:prstGeom>
           <a:solidFill>
-            <a:srgbClr val="E11D48"/>
+            <a:srgbClr val="F43F5E"/>
           </a:solidFill>
           <a:ln/>
         </p:spPr>
@@ -4928,7 +4928,7 @@
             <a:avLst/>
           </a:prstGeom>
           <a:solidFill>
-            <a:srgbClr val="E11D48"/>
+            <a:srgbClr val="F43F5E"/>
           </a:solidFill>
           <a:ln/>
         </p:spPr>
@@ -4999,7 +4999,7 @@
             <a:r>
               <a:rPr lang="en-US" sz="2100" b="1" dirty="0">
                 <a:solidFill>
-                  <a:srgbClr val="0F172A"/>
+                  <a:srgbClr val="EAF1FB"/>
                 </a:solidFill>
                 <a:latin typeface="Trebuchet MS" pitchFamily="34" charset="0"/>
                 <a:ea typeface="Trebuchet MS" pitchFamily="34" charset="-122"/>
@@ -5038,7 +5038,7 @@
             <a:r>
               <a:rPr lang="en-US" sz="1650" i="1" dirty="0">
                 <a:solidFill>
-                  <a:srgbClr val="0F172A"/>
+                  <a:srgbClr val="EAF1FB"/>
                 </a:solidFill>
                 <a:latin typeface="Calibri" pitchFamily="34" charset="0"/>
                 <a:ea typeface="Calibri" pitchFamily="34" charset="-122"/>
@@ -5067,7 +5067,7 @@
           <a:noFill/>
           <a:ln w="12700">
             <a:solidFill>
-              <a:srgbClr val="E3E9F1"/>
+              <a:srgbClr val="2A3A59"/>
             </a:solidFill>
             <a:prstDash val="solid"/>
           </a:ln>
@@ -5100,7 +5100,7 @@
             <a:r>
               <a:rPr lang="en-US" sz="1150" b="1" spc="100" kern="0" dirty="0">
                 <a:solidFill>
-                  <a:srgbClr val="E11D48"/>
+                  <a:srgbClr val="F43F5E"/>
                 </a:solidFill>
                 <a:latin typeface="Consolas" pitchFamily="34" charset="0"/>
                 <a:ea typeface="Consolas" pitchFamily="34" charset="-122"/>
@@ -5142,7 +5142,7 @@
             <a:r>
               <a:rPr lang="en-US" sz="1500" dirty="0">
                 <a:solidFill>
-                  <a:srgbClr val="566377"/>
+                  <a:srgbClr val="9FB0CC"/>
                 </a:solidFill>
                 <a:latin typeface="Calibri" pitchFamily="34" charset="0"/>
                 <a:ea typeface="Calibri" pitchFamily="34" charset="-122"/>
@@ -5162,7 +5162,7 @@
             <a:r>
               <a:rPr lang="en-US" sz="1500" dirty="0">
                 <a:solidFill>
-                  <a:srgbClr val="566377"/>
+                  <a:srgbClr val="9FB0CC"/>
                 </a:solidFill>
                 <a:latin typeface="Calibri" pitchFamily="34" charset="0"/>
                 <a:ea typeface="Calibri" pitchFamily="34" charset="-122"/>
@@ -5188,7 +5188,7 @@
     <p:bg>
       <p:bgPr>
         <a:solidFill>
-          <a:srgbClr val="F7FAFC"/>
+          <a:srgbClr val="0B1220"/>
         </a:solidFill>
       </p:bgPr>
     </p:bg>
@@ -5233,7 +5233,7 @@
             <a:r>
               <a:rPr lang="en-US" sz="1250" b="1" spc="200" kern="0" dirty="0">
                 <a:solidFill>
-                  <a:srgbClr val="0D9488"/>
+                  <a:srgbClr val="2DD4BF"/>
                 </a:solidFill>
                 <a:latin typeface="Consolas" pitchFamily="34" charset="0"/>
                 <a:ea typeface="Consolas" pitchFamily="34" charset="-122"/>
@@ -5247,7 +5247,7 @@
             <a:r>
               <a:rPr lang="en-US" sz="1250" spc="200" kern="0" dirty="0">
                 <a:solidFill>
-                  <a:srgbClr val="566377"/>
+                  <a:srgbClr val="9FB0CC"/>
                 </a:solidFill>
                 <a:latin typeface="Consolas" pitchFamily="34" charset="0"/>
                 <a:ea typeface="Consolas" pitchFamily="34" charset="-122"/>
@@ -5286,7 +5286,7 @@
             <a:r>
               <a:rPr lang="en-US" sz="3100" b="1" dirty="0">
                 <a:solidFill>
-                  <a:srgbClr val="0F172A"/>
+                  <a:srgbClr val="EAF1FB"/>
                 </a:solidFill>
                 <a:latin typeface="Trebuchet MS" pitchFamily="34" charset="0"/>
                 <a:ea typeface="Trebuchet MS" pitchFamily="34" charset="-122"/>
@@ -5313,18 +5313,18 @@
             <a:avLst/>
           </a:prstGeom>
           <a:solidFill>
-            <a:srgbClr val="FFFFFF"/>
+            <a:srgbClr val="141F38"/>
           </a:solidFill>
           <a:ln w="12700">
             <a:solidFill>
-              <a:srgbClr val="E3E9F1"/>
+              <a:srgbClr val="2A3A59"/>
             </a:solidFill>
             <a:prstDash val="solid"/>
           </a:ln>
           <a:effectLst>
-            <a:outerShdw sx="100000" sy="100000" kx="0" ky="0" algn="bl" rotWithShape="0" blurRad="114300" dist="38100" dir="5400000">
-              <a:srgbClr val="0F172A">
-                <a:alpha val="10000"/>
+            <a:outerShdw sx="100000" sy="100000" kx="0" ky="0" algn="bl" rotWithShape="0" blurRad="127000" dist="38100" dir="5400000">
+              <a:srgbClr val="000000">
+                <a:alpha val="35000"/>
               </a:srgbClr>
             </a:outerShdw>
           </a:effectLst>
@@ -5345,7 +5345,7 @@
             <a:avLst/>
           </a:prstGeom>
           <a:solidFill>
-            <a:srgbClr val="059669"/>
+            <a:srgbClr val="10B981"/>
           </a:solidFill>
           <a:ln/>
         </p:spPr>
@@ -5377,7 +5377,7 @@
             <a:r>
               <a:rPr lang="en-US" sz="4000" b="1" dirty="0">
                 <a:solidFill>
-                  <a:srgbClr val="059669"/>
+                  <a:srgbClr val="10B981"/>
                 </a:solidFill>
                 <a:latin typeface="Trebuchet MS" pitchFamily="34" charset="0"/>
                 <a:ea typeface="Trebuchet MS" pitchFamily="34" charset="-122"/>
@@ -5416,7 +5416,7 @@
             <a:r>
               <a:rPr lang="en-US" sz="2000" b="1" dirty="0">
                 <a:solidFill>
-                  <a:srgbClr val="0F172A"/>
+                  <a:srgbClr val="EAF1FB"/>
                 </a:solidFill>
                 <a:latin typeface="Trebuchet MS" pitchFamily="34" charset="0"/>
                 <a:ea typeface="Trebuchet MS" pitchFamily="34" charset="-122"/>
@@ -5455,7 +5455,7 @@
             <a:r>
               <a:rPr lang="en-US" sz="1350" dirty="0">
                 <a:solidFill>
-                  <a:srgbClr val="566377"/>
+                  <a:srgbClr val="9FB0CC"/>
                 </a:solidFill>
                 <a:latin typeface="Calibri" pitchFamily="34" charset="0"/>
                 <a:ea typeface="Calibri" pitchFamily="34" charset="-122"/>
@@ -5494,7 +5494,7 @@
             <a:r>
               <a:rPr lang="en-US" sz="1050" b="1" spc="200" kern="0" dirty="0">
                 <a:solidFill>
-                  <a:srgbClr val="059669"/>
+                  <a:srgbClr val="10B981"/>
                 </a:solidFill>
                 <a:latin typeface="Consolas" pitchFamily="34" charset="0"/>
                 <a:ea typeface="Consolas" pitchFamily="34" charset="-122"/>
@@ -5533,7 +5533,7 @@
             <a:r>
               <a:rPr lang="en-US" sz="1400" dirty="0">
                 <a:solidFill>
-                  <a:srgbClr val="0F172A"/>
+                  <a:srgbClr val="EAF1FB"/>
                 </a:solidFill>
                 <a:latin typeface="Consolas" pitchFamily="34" charset="0"/>
                 <a:ea typeface="Consolas" pitchFamily="34" charset="-122"/>
@@ -5560,18 +5560,18 @@
             <a:avLst/>
           </a:prstGeom>
           <a:solidFill>
-            <a:srgbClr val="FFFFFF"/>
+            <a:srgbClr val="141F38"/>
           </a:solidFill>
           <a:ln w="12700">
             <a:solidFill>
-              <a:srgbClr val="E3E9F1"/>
+              <a:srgbClr val="2A3A59"/>
             </a:solidFill>
             <a:prstDash val="solid"/>
           </a:ln>
           <a:effectLst>
-            <a:outerShdw sx="100000" sy="100000" kx="0" ky="0" algn="bl" rotWithShape="0" blurRad="114300" dist="38100" dir="5400000">
-              <a:srgbClr val="0F172A">
-                <a:alpha val="10000"/>
+            <a:outerShdw sx="100000" sy="100000" kx="0" ky="0" algn="bl" rotWithShape="0" blurRad="127000" dist="38100" dir="5400000">
+              <a:srgbClr val="000000">
+                <a:alpha val="35000"/>
               </a:srgbClr>
             </a:outerShdw>
           </a:effectLst>
@@ -5592,7 +5592,7 @@
             <a:avLst/>
           </a:prstGeom>
           <a:solidFill>
-            <a:srgbClr val="2563EB"/>
+            <a:srgbClr val="3B82F6"/>
           </a:solidFill>
           <a:ln/>
         </p:spPr>
@@ -5624,7 +5624,7 @@
             <a:r>
               <a:rPr lang="en-US" sz="4000" b="1" dirty="0">
                 <a:solidFill>
-                  <a:srgbClr val="2563EB"/>
+                  <a:srgbClr val="3B82F6"/>
                 </a:solidFill>
                 <a:latin typeface="Trebuchet MS" pitchFamily="34" charset="0"/>
                 <a:ea typeface="Trebuchet MS" pitchFamily="34" charset="-122"/>
@@ -5663,7 +5663,7 @@
             <a:r>
               <a:rPr lang="en-US" sz="2000" b="1" dirty="0">
                 <a:solidFill>
-                  <a:srgbClr val="0F172A"/>
+                  <a:srgbClr val="EAF1FB"/>
                 </a:solidFill>
                 <a:latin typeface="Trebuchet MS" pitchFamily="34" charset="0"/>
                 <a:ea typeface="Trebuchet MS" pitchFamily="34" charset="-122"/>
@@ -5702,7 +5702,7 @@
             <a:r>
               <a:rPr lang="en-US" sz="1350" dirty="0">
                 <a:solidFill>
-                  <a:srgbClr val="566377"/>
+                  <a:srgbClr val="9FB0CC"/>
                 </a:solidFill>
                 <a:latin typeface="Calibri" pitchFamily="34" charset="0"/>
                 <a:ea typeface="Calibri" pitchFamily="34" charset="-122"/>
@@ -5741,7 +5741,7 @@
             <a:r>
               <a:rPr lang="en-US" sz="1050" b="1" spc="200" kern="0" dirty="0">
                 <a:solidFill>
-                  <a:srgbClr val="2563EB"/>
+                  <a:srgbClr val="3B82F6"/>
                 </a:solidFill>
                 <a:latin typeface="Consolas" pitchFamily="34" charset="0"/>
                 <a:ea typeface="Consolas" pitchFamily="34" charset="-122"/>
@@ -5780,7 +5780,7 @@
             <a:r>
               <a:rPr lang="en-US" sz="1400" dirty="0">
                 <a:solidFill>
-                  <a:srgbClr val="0F172A"/>
+                  <a:srgbClr val="EAF1FB"/>
                 </a:solidFill>
                 <a:latin typeface="Consolas" pitchFamily="34" charset="0"/>
                 <a:ea typeface="Consolas" pitchFamily="34" charset="-122"/>
@@ -5807,18 +5807,18 @@
             <a:avLst/>
           </a:prstGeom>
           <a:solidFill>
-            <a:srgbClr val="FFFFFF"/>
+            <a:srgbClr val="141F38"/>
           </a:solidFill>
           <a:ln w="12700">
             <a:solidFill>
-              <a:srgbClr val="E3E9F1"/>
+              <a:srgbClr val="2A3A59"/>
             </a:solidFill>
             <a:prstDash val="solid"/>
           </a:ln>
           <a:effectLst>
-            <a:outerShdw sx="100000" sy="100000" kx="0" ky="0" algn="bl" rotWithShape="0" blurRad="114300" dist="38100" dir="5400000">
-              <a:srgbClr val="0F172A">
-                <a:alpha val="10000"/>
+            <a:outerShdw sx="100000" sy="100000" kx="0" ky="0" algn="bl" rotWithShape="0" blurRad="127000" dist="38100" dir="5400000">
+              <a:srgbClr val="000000">
+                <a:alpha val="35000"/>
               </a:srgbClr>
             </a:outerShdw>
           </a:effectLst>
@@ -5839,7 +5839,7 @@
             <a:avLst/>
           </a:prstGeom>
           <a:solidFill>
-            <a:srgbClr val="7C3AED"/>
+            <a:srgbClr val="8B5CF6"/>
           </a:solidFill>
           <a:ln/>
         </p:spPr>
@@ -5871,7 +5871,7 @@
             <a:r>
               <a:rPr lang="en-US" sz="4000" b="1" dirty="0">
                 <a:solidFill>
-                  <a:srgbClr val="7C3AED"/>
+                  <a:srgbClr val="8B5CF6"/>
                 </a:solidFill>
                 <a:latin typeface="Trebuchet MS" pitchFamily="34" charset="0"/>
                 <a:ea typeface="Trebuchet MS" pitchFamily="34" charset="-122"/>
@@ -5910,7 +5910,7 @@
             <a:r>
               <a:rPr lang="en-US" sz="2000" b="1" dirty="0">
                 <a:solidFill>
-                  <a:srgbClr val="0F172A"/>
+                  <a:srgbClr val="EAF1FB"/>
                 </a:solidFill>
                 <a:latin typeface="Trebuchet MS" pitchFamily="34" charset="0"/>
                 <a:ea typeface="Trebuchet MS" pitchFamily="34" charset="-122"/>
@@ -5949,7 +5949,7 @@
             <a:r>
               <a:rPr lang="en-US" sz="1350" dirty="0">
                 <a:solidFill>
-                  <a:srgbClr val="566377"/>
+                  <a:srgbClr val="9FB0CC"/>
                 </a:solidFill>
                 <a:latin typeface="Calibri" pitchFamily="34" charset="0"/>
                 <a:ea typeface="Calibri" pitchFamily="34" charset="-122"/>
@@ -5988,7 +5988,7 @@
             <a:r>
               <a:rPr lang="en-US" sz="1050" b="1" spc="200" kern="0" dirty="0">
                 <a:solidFill>
-                  <a:srgbClr val="7C3AED"/>
+                  <a:srgbClr val="8B5CF6"/>
                 </a:solidFill>
                 <a:latin typeface="Consolas" pitchFamily="34" charset="0"/>
                 <a:ea typeface="Consolas" pitchFamily="34" charset="-122"/>
@@ -6027,7 +6027,7 @@
             <a:r>
               <a:rPr lang="en-US" sz="1400" dirty="0">
                 <a:solidFill>
-                  <a:srgbClr val="0F172A"/>
+                  <a:srgbClr val="EAF1FB"/>
                 </a:solidFill>
                 <a:latin typeface="Consolas" pitchFamily="34" charset="0"/>
                 <a:ea typeface="Consolas" pitchFamily="34" charset="-122"/>
@@ -6254,7 +6254,7 @@
             <a:r>
               <a:rPr lang="en-US" sz="1400" b="1" spc="200" kern="0" dirty="0">
                 <a:solidFill>
-                  <a:srgbClr val="E11D48"/>
+                  <a:srgbClr val="F43F5E"/>
                 </a:solidFill>
                 <a:latin typeface="Consolas" pitchFamily="34" charset="0"/>
                 <a:ea typeface="Consolas" pitchFamily="34" charset="-122"/>
@@ -6320,7 +6320,7 @@
             <a:avLst/>
           </a:prstGeom>
           <a:solidFill>
-            <a:srgbClr val="131F36"/>
+            <a:srgbClr val="141F38"/>
           </a:solidFill>
           <a:ln w="12700">
             <a:solidFill>
@@ -6352,7 +6352,7 @@
             <a:avLst/>
           </a:prstGeom>
           <a:solidFill>
-            <a:srgbClr val="2563EB"/>
+            <a:srgbClr val="3B82F6"/>
           </a:solidFill>
           <a:ln/>
         </p:spPr>
@@ -6384,7 +6384,7 @@
             <a:r>
               <a:rPr lang="en-US" sz="1100" b="1" spc="200" kern="0" dirty="0">
                 <a:solidFill>
-                  <a:srgbClr val="2563EB"/>
+                  <a:srgbClr val="3B82F6"/>
                 </a:solidFill>
                 <a:latin typeface="Consolas" pitchFamily="34" charset="0"/>
                 <a:ea typeface="Consolas" pitchFamily="34" charset="-122"/>
@@ -6465,7 +6465,7 @@
             <a:r>
               <a:rPr lang="en-US" sz="1350" dirty="0">
                 <a:solidFill>
-                  <a:srgbClr val="94A6C2"/>
+                  <a:srgbClr val="9FB0CC"/>
                 </a:solidFill>
                 <a:latin typeface="Calibri" pitchFamily="34" charset="0"/>
                 <a:ea typeface="Calibri" pitchFamily="34" charset="-122"/>
@@ -6492,7 +6492,7 @@
             <a:avLst/>
           </a:prstGeom>
           <a:solidFill>
-            <a:srgbClr val="131F36"/>
+            <a:srgbClr val="141F38"/>
           </a:solidFill>
           <a:ln w="12700">
             <a:solidFill>
@@ -6524,7 +6524,7 @@
             <a:avLst/>
           </a:prstGeom>
           <a:solidFill>
-            <a:srgbClr val="2563EB"/>
+            <a:srgbClr val="3B82F6"/>
           </a:solidFill>
           <a:ln/>
         </p:spPr>
@@ -6556,7 +6556,7 @@
             <a:r>
               <a:rPr lang="en-US" sz="1100" b="1" spc="200" kern="0" dirty="0">
                 <a:solidFill>
-                  <a:srgbClr val="2563EB"/>
+                  <a:srgbClr val="3B82F6"/>
                 </a:solidFill>
                 <a:latin typeface="Consolas" pitchFamily="34" charset="0"/>
                 <a:ea typeface="Consolas" pitchFamily="34" charset="-122"/>
@@ -6637,7 +6637,7 @@
             <a:r>
               <a:rPr lang="en-US" sz="1350" dirty="0">
                 <a:solidFill>
-                  <a:srgbClr val="94A6C2"/>
+                  <a:srgbClr val="9FB0CC"/>
                 </a:solidFill>
                 <a:latin typeface="Calibri" pitchFamily="34" charset="0"/>
                 <a:ea typeface="Calibri" pitchFamily="34" charset="-122"/>
@@ -6664,7 +6664,7 @@
             <a:avLst/>
           </a:prstGeom>
           <a:solidFill>
-            <a:srgbClr val="131F36"/>
+            <a:srgbClr val="141F38"/>
           </a:solidFill>
           <a:ln w="12700">
             <a:solidFill>
@@ -6696,7 +6696,7 @@
             <a:avLst/>
           </a:prstGeom>
           <a:solidFill>
-            <a:srgbClr val="059669"/>
+            <a:srgbClr val="10B981"/>
           </a:solidFill>
           <a:ln/>
         </p:spPr>
@@ -6728,7 +6728,7 @@
             <a:r>
               <a:rPr lang="en-US" sz="1100" b="1" spc="200" kern="0" dirty="0">
                 <a:solidFill>
-                  <a:srgbClr val="059669"/>
+                  <a:srgbClr val="10B981"/>
                 </a:solidFill>
                 <a:latin typeface="Consolas" pitchFamily="34" charset="0"/>
                 <a:ea typeface="Consolas" pitchFamily="34" charset="-122"/>
@@ -6809,7 +6809,7 @@
             <a:r>
               <a:rPr lang="en-US" sz="1350" dirty="0">
                 <a:solidFill>
-                  <a:srgbClr val="94A6C2"/>
+                  <a:srgbClr val="9FB0CC"/>
                 </a:solidFill>
                 <a:latin typeface="Calibri" pitchFamily="34" charset="0"/>
                 <a:ea typeface="Calibri" pitchFamily="34" charset="-122"/>
@@ -6836,7 +6836,7 @@
             <a:avLst/>
           </a:prstGeom>
           <a:solidFill>
-            <a:srgbClr val="131F36"/>
+            <a:srgbClr val="141F38"/>
           </a:solidFill>
           <a:ln w="12700">
             <a:solidFill>
@@ -6868,7 +6868,7 @@
             <a:avLst/>
           </a:prstGeom>
           <a:solidFill>
-            <a:srgbClr val="E11D48"/>
+            <a:srgbClr val="F43F5E"/>
           </a:solidFill>
           <a:ln/>
         </p:spPr>
@@ -6900,7 +6900,7 @@
             <a:r>
               <a:rPr lang="en-US" sz="1100" b="1" spc="200" kern="0" dirty="0">
                 <a:solidFill>
-                  <a:srgbClr val="E11D48"/>
+                  <a:srgbClr val="F43F5E"/>
                 </a:solidFill>
                 <a:latin typeface="Consolas" pitchFamily="34" charset="0"/>
                 <a:ea typeface="Consolas" pitchFamily="34" charset="-122"/>
@@ -6981,7 +6981,7 @@
             <a:r>
               <a:rPr lang="en-US" sz="1350" dirty="0">
                 <a:solidFill>
-                  <a:srgbClr val="94A6C2"/>
+                  <a:srgbClr val="9FB0CC"/>
                 </a:solidFill>
                 <a:latin typeface="Calibri" pitchFamily="34" charset="0"/>
                 <a:ea typeface="Calibri" pitchFamily="34" charset="-122"/>
@@ -7020,7 +7020,7 @@
             <a:r>
               <a:rPr lang="en-US" sz="1400" i="1" dirty="0">
                 <a:solidFill>
-                  <a:srgbClr val="94A6C2"/>
+                  <a:srgbClr val="9FB0CC"/>
                 </a:solidFill>
                 <a:latin typeface="Calibri" pitchFamily="34" charset="0"/>
                 <a:ea typeface="Calibri" pitchFamily="34" charset="-122"/>
@@ -7046,7 +7046,7 @@
     <p:bg>
       <p:bgPr>
         <a:solidFill>
-          <a:srgbClr val="F7FAFC"/>
+          <a:srgbClr val="0B1220"/>
         </a:solidFill>
       </p:bgPr>
     </p:bg>
@@ -7091,7 +7091,7 @@
             <a:r>
               <a:rPr lang="en-US" sz="1250" b="1" spc="200" kern="0" dirty="0">
                 <a:solidFill>
-                  <a:srgbClr val="0D9488"/>
+                  <a:srgbClr val="2DD4BF"/>
                 </a:solidFill>
                 <a:latin typeface="Consolas" pitchFamily="34" charset="0"/>
                 <a:ea typeface="Consolas" pitchFamily="34" charset="-122"/>
@@ -7105,7 +7105,7 @@
             <a:r>
               <a:rPr lang="en-US" sz="1250" spc="200" kern="0" dirty="0">
                 <a:solidFill>
-                  <a:srgbClr val="566377"/>
+                  <a:srgbClr val="9FB0CC"/>
                 </a:solidFill>
                 <a:latin typeface="Consolas" pitchFamily="34" charset="0"/>
                 <a:ea typeface="Consolas" pitchFamily="34" charset="-122"/>
@@ -7144,7 +7144,7 @@
             <a:r>
               <a:rPr lang="en-US" sz="3100" b="1" dirty="0">
                 <a:solidFill>
-                  <a:srgbClr val="0F172A"/>
+                  <a:srgbClr val="EAF1FB"/>
                 </a:solidFill>
                 <a:latin typeface="Trebuchet MS" pitchFamily="34" charset="0"/>
                 <a:ea typeface="Trebuchet MS" pitchFamily="34" charset="-122"/>
@@ -7171,18 +7171,18 @@
             <a:avLst/>
           </a:prstGeom>
           <a:solidFill>
-            <a:srgbClr val="FFFFFF"/>
+            <a:srgbClr val="141F38"/>
           </a:solidFill>
           <a:ln w="12700">
             <a:solidFill>
-              <a:srgbClr val="E3E9F1"/>
+              <a:srgbClr val="2A3A59"/>
             </a:solidFill>
             <a:prstDash val="solid"/>
           </a:ln>
           <a:effectLst>
-            <a:outerShdw sx="100000" sy="100000" kx="0" ky="0" algn="bl" rotWithShape="0" blurRad="114300" dist="38100" dir="5400000">
-              <a:srgbClr val="0F172A">
-                <a:alpha val="10000"/>
+            <a:outerShdw sx="100000" sy="100000" kx="0" ky="0" algn="bl" rotWithShape="0" blurRad="127000" dist="38100" dir="5400000">
+              <a:srgbClr val="000000">
+                <a:alpha val="35000"/>
               </a:srgbClr>
             </a:outerShdw>
           </a:effectLst>
@@ -7203,7 +7203,7 @@
             <a:avLst/>
           </a:prstGeom>
           <a:solidFill>
-            <a:srgbClr val="2563EB"/>
+            <a:srgbClr val="3B82F6"/>
           </a:solidFill>
           <a:ln/>
         </p:spPr>
@@ -7223,7 +7223,7 @@
             <a:avLst/>
           </a:prstGeom>
           <a:solidFill>
-            <a:srgbClr val="2563EB"/>
+            <a:srgbClr val="3B82F6"/>
           </a:solidFill>
           <a:ln/>
         </p:spPr>
@@ -7294,7 +7294,7 @@
             <a:r>
               <a:rPr lang="en-US" sz="2000" b="1" dirty="0">
                 <a:solidFill>
-                  <a:srgbClr val="0F172A"/>
+                  <a:srgbClr val="EAF1FB"/>
                 </a:solidFill>
                 <a:latin typeface="Trebuchet MS" pitchFamily="34" charset="0"/>
                 <a:ea typeface="Trebuchet MS" pitchFamily="34" charset="-122"/>
@@ -7336,7 +7336,7 @@
             <a:r>
               <a:rPr lang="en-US" sz="1450" dirty="0">
                 <a:solidFill>
-                  <a:srgbClr val="566377"/>
+                  <a:srgbClr val="9FB0CC"/>
                 </a:solidFill>
                 <a:latin typeface="Calibri" pitchFamily="34" charset="0"/>
                 <a:ea typeface="Calibri" pitchFamily="34" charset="-122"/>
@@ -7363,18 +7363,18 @@
             <a:avLst/>
           </a:prstGeom>
           <a:solidFill>
-            <a:srgbClr val="FFFFFF"/>
+            <a:srgbClr val="141F38"/>
           </a:solidFill>
           <a:ln w="12700">
             <a:solidFill>
-              <a:srgbClr val="E3E9F1"/>
+              <a:srgbClr val="2A3A59"/>
             </a:solidFill>
             <a:prstDash val="solid"/>
           </a:ln>
           <a:effectLst>
-            <a:outerShdw sx="100000" sy="100000" kx="0" ky="0" algn="bl" rotWithShape="0" blurRad="114300" dist="38100" dir="5400000">
-              <a:srgbClr val="0F172A">
-                <a:alpha val="10000"/>
+            <a:outerShdw sx="100000" sy="100000" kx="0" ky="0" algn="bl" rotWithShape="0" blurRad="127000" dist="38100" dir="5400000">
+              <a:srgbClr val="000000">
+                <a:alpha val="35000"/>
               </a:srgbClr>
             </a:outerShdw>
           </a:effectLst>
@@ -7395,7 +7395,7 @@
             <a:avLst/>
           </a:prstGeom>
           <a:solidFill>
-            <a:srgbClr val="059669"/>
+            <a:srgbClr val="10B981"/>
           </a:solidFill>
           <a:ln/>
         </p:spPr>
@@ -7415,7 +7415,7 @@
             <a:avLst/>
           </a:prstGeom>
           <a:solidFill>
-            <a:srgbClr val="059669"/>
+            <a:srgbClr val="10B981"/>
           </a:solidFill>
           <a:ln/>
         </p:spPr>
@@ -7486,7 +7486,7 @@
             <a:r>
               <a:rPr lang="en-US" sz="2000" b="1" dirty="0">
                 <a:solidFill>
-                  <a:srgbClr val="0F172A"/>
+                  <a:srgbClr val="EAF1FB"/>
                 </a:solidFill>
                 <a:latin typeface="Trebuchet MS" pitchFamily="34" charset="0"/>
                 <a:ea typeface="Trebuchet MS" pitchFamily="34" charset="-122"/>
@@ -7528,7 +7528,7 @@
             <a:r>
               <a:rPr lang="en-US" sz="1450" dirty="0">
                 <a:solidFill>
-                  <a:srgbClr val="566377"/>
+                  <a:srgbClr val="9FB0CC"/>
                 </a:solidFill>
                 <a:latin typeface="Calibri" pitchFamily="34" charset="0"/>
                 <a:ea typeface="Calibri" pitchFamily="34" charset="-122"/>
@@ -7555,18 +7555,18 @@
             <a:avLst/>
           </a:prstGeom>
           <a:solidFill>
-            <a:srgbClr val="FFFFFF"/>
+            <a:srgbClr val="141F38"/>
           </a:solidFill>
           <a:ln w="12700">
             <a:solidFill>
-              <a:srgbClr val="E3E9F1"/>
+              <a:srgbClr val="2A3A59"/>
             </a:solidFill>
             <a:prstDash val="solid"/>
           </a:ln>
           <a:effectLst>
-            <a:outerShdw sx="100000" sy="100000" kx="0" ky="0" algn="bl" rotWithShape="0" blurRad="114300" dist="38100" dir="5400000">
-              <a:srgbClr val="0F172A">
-                <a:alpha val="10000"/>
+            <a:outerShdw sx="100000" sy="100000" kx="0" ky="0" algn="bl" rotWithShape="0" blurRad="127000" dist="38100" dir="5400000">
+              <a:srgbClr val="000000">
+                <a:alpha val="35000"/>
               </a:srgbClr>
             </a:outerShdw>
           </a:effectLst>
@@ -7587,7 +7587,7 @@
             <a:avLst/>
           </a:prstGeom>
           <a:solidFill>
-            <a:srgbClr val="E11D48"/>
+            <a:srgbClr val="F43F5E"/>
           </a:solidFill>
           <a:ln/>
         </p:spPr>
@@ -7607,7 +7607,7 @@
             <a:avLst/>
           </a:prstGeom>
           <a:solidFill>
-            <a:srgbClr val="E11D48"/>
+            <a:srgbClr val="F43F5E"/>
           </a:solidFill>
           <a:ln/>
         </p:spPr>
@@ -7678,7 +7678,7 @@
             <a:r>
               <a:rPr lang="en-US" sz="2000" b="1" dirty="0">
                 <a:solidFill>
-                  <a:srgbClr val="0F172A"/>
+                  <a:srgbClr val="EAF1FB"/>
                 </a:solidFill>
                 <a:latin typeface="Trebuchet MS" pitchFamily="34" charset="0"/>
                 <a:ea typeface="Trebuchet MS" pitchFamily="34" charset="-122"/>
@@ -7720,7 +7720,7 @@
             <a:r>
               <a:rPr lang="en-US" sz="1450" dirty="0">
                 <a:solidFill>
-                  <a:srgbClr val="566377"/>
+                  <a:srgbClr val="9FB0CC"/>
                 </a:solidFill>
                 <a:latin typeface="Calibri" pitchFamily="34" charset="0"/>
                 <a:ea typeface="Calibri" pitchFamily="34" charset="-122"/>
@@ -7746,7 +7746,7 @@
     <p:bg>
       <p:bgPr>
         <a:solidFill>
-          <a:srgbClr val="F7FAFC"/>
+          <a:srgbClr val="0B1220"/>
         </a:solidFill>
       </p:bgPr>
     </p:bg>
@@ -7791,7 +7791,7 @@
             <a:r>
               <a:rPr lang="en-US" sz="1250" b="1" spc="200" kern="0" dirty="0">
                 <a:solidFill>
-                  <a:srgbClr val="0D9488"/>
+                  <a:srgbClr val="2DD4BF"/>
                 </a:solidFill>
                 <a:latin typeface="Consolas" pitchFamily="34" charset="0"/>
                 <a:ea typeface="Consolas" pitchFamily="34" charset="-122"/>
@@ -7805,7 +7805,7 @@
             <a:r>
               <a:rPr lang="en-US" sz="1250" spc="200" kern="0" dirty="0">
                 <a:solidFill>
-                  <a:srgbClr val="566377"/>
+                  <a:srgbClr val="9FB0CC"/>
                 </a:solidFill>
                 <a:latin typeface="Consolas" pitchFamily="34" charset="0"/>
                 <a:ea typeface="Consolas" pitchFamily="34" charset="-122"/>
@@ -7844,7 +7844,7 @@
             <a:r>
               <a:rPr lang="en-US" sz="3100" b="1" dirty="0">
                 <a:solidFill>
-                  <a:srgbClr val="0F172A"/>
+                  <a:srgbClr val="EAF1FB"/>
                 </a:solidFill>
                 <a:latin typeface="Trebuchet MS" pitchFamily="34" charset="0"/>
                 <a:ea typeface="Trebuchet MS" pitchFamily="34" charset="-122"/>
@@ -7871,18 +7871,18 @@
             <a:avLst/>
           </a:prstGeom>
           <a:solidFill>
-            <a:srgbClr val="FFFFFF"/>
+            <a:srgbClr val="141F38"/>
           </a:solidFill>
           <a:ln w="12700">
             <a:solidFill>
-              <a:srgbClr val="E3E9F1"/>
+              <a:srgbClr val="2A3A59"/>
             </a:solidFill>
             <a:prstDash val="solid"/>
           </a:ln>
           <a:effectLst>
-            <a:outerShdw sx="100000" sy="100000" kx="0" ky="0" algn="bl" rotWithShape="0" blurRad="114300" dist="38100" dir="5400000">
-              <a:srgbClr val="0F172A">
-                <a:alpha val="10000"/>
+            <a:outerShdw sx="100000" sy="100000" kx="0" ky="0" algn="bl" rotWithShape="0" blurRad="127000" dist="38100" dir="5400000">
+              <a:srgbClr val="000000">
+                <a:alpha val="35000"/>
               </a:srgbClr>
             </a:outerShdw>
           </a:effectLst>
@@ -7903,7 +7903,7 @@
             <a:avLst/>
           </a:prstGeom>
           <a:solidFill>
-            <a:srgbClr val="2563EB"/>
+            <a:srgbClr val="3B82F6"/>
           </a:solidFill>
           <a:ln/>
         </p:spPr>
@@ -7935,7 +7935,7 @@
             <a:r>
               <a:rPr lang="en-US" sz="1800" b="1" dirty="0">
                 <a:solidFill>
-                  <a:srgbClr val="2563EB"/>
+                  <a:srgbClr val="3B82F6"/>
                 </a:solidFill>
                 <a:latin typeface="Trebuchet MS" pitchFamily="34" charset="0"/>
                 <a:ea typeface="Trebuchet MS" pitchFamily="34" charset="-122"/>
@@ -7977,7 +7977,7 @@
             <a:r>
               <a:rPr lang="en-US" sz="1400" dirty="0">
                 <a:solidFill>
-                  <a:srgbClr val="566377"/>
+                  <a:srgbClr val="9FB0CC"/>
                 </a:solidFill>
                 <a:latin typeface="Calibri" pitchFamily="34" charset="0"/>
                 <a:ea typeface="Calibri" pitchFamily="34" charset="-122"/>
@@ -8004,18 +8004,18 @@
             <a:avLst/>
           </a:prstGeom>
           <a:solidFill>
-            <a:srgbClr val="FFFFFF"/>
+            <a:srgbClr val="141F38"/>
           </a:solidFill>
           <a:ln w="12700">
             <a:solidFill>
-              <a:srgbClr val="E3E9F1"/>
+              <a:srgbClr val="2A3A59"/>
             </a:solidFill>
             <a:prstDash val="solid"/>
           </a:ln>
           <a:effectLst>
-            <a:outerShdw sx="100000" sy="100000" kx="0" ky="0" algn="bl" rotWithShape="0" blurRad="114300" dist="38100" dir="5400000">
-              <a:srgbClr val="0F172A">
-                <a:alpha val="10000"/>
+            <a:outerShdw sx="100000" sy="100000" kx="0" ky="0" algn="bl" rotWithShape="0" blurRad="127000" dist="38100" dir="5400000">
+              <a:srgbClr val="000000">
+                <a:alpha val="35000"/>
               </a:srgbClr>
             </a:outerShdw>
           </a:effectLst>
@@ -8036,7 +8036,7 @@
             <a:avLst/>
           </a:prstGeom>
           <a:solidFill>
-            <a:srgbClr val="059669"/>
+            <a:srgbClr val="10B981"/>
           </a:solidFill>
           <a:ln/>
         </p:spPr>
@@ -8068,7 +8068,7 @@
             <a:r>
               <a:rPr lang="en-US" sz="1800" b="1" dirty="0">
                 <a:solidFill>
-                  <a:srgbClr val="059669"/>
+                  <a:srgbClr val="10B981"/>
                 </a:solidFill>
                 <a:latin typeface="Trebuchet MS" pitchFamily="34" charset="0"/>
                 <a:ea typeface="Trebuchet MS" pitchFamily="34" charset="-122"/>
@@ -8110,7 +8110,7 @@
             <a:r>
               <a:rPr lang="en-US" sz="1400" dirty="0">
                 <a:solidFill>
-                  <a:srgbClr val="566377"/>
+                  <a:srgbClr val="9FB0CC"/>
                 </a:solidFill>
                 <a:latin typeface="Calibri" pitchFamily="34" charset="0"/>
                 <a:ea typeface="Calibri" pitchFamily="34" charset="-122"/>
@@ -8137,18 +8137,18 @@
             <a:avLst/>
           </a:prstGeom>
           <a:solidFill>
-            <a:srgbClr val="FFFFFF"/>
+            <a:srgbClr val="141F38"/>
           </a:solidFill>
           <a:ln w="12700">
             <a:solidFill>
-              <a:srgbClr val="E3E9F1"/>
+              <a:srgbClr val="2A3A59"/>
             </a:solidFill>
             <a:prstDash val="solid"/>
           </a:ln>
           <a:effectLst>
-            <a:outerShdw sx="100000" sy="100000" kx="0" ky="0" algn="bl" rotWithShape="0" blurRad="114300" dist="38100" dir="5400000">
-              <a:srgbClr val="0F172A">
-                <a:alpha val="10000"/>
+            <a:outerShdw sx="100000" sy="100000" kx="0" ky="0" algn="bl" rotWithShape="0" blurRad="127000" dist="38100" dir="5400000">
+              <a:srgbClr val="000000">
+                <a:alpha val="35000"/>
               </a:srgbClr>
             </a:outerShdw>
           </a:effectLst>
@@ -8169,7 +8169,7 @@
             <a:avLst/>
           </a:prstGeom>
           <a:solidFill>
-            <a:srgbClr val="7C3AED"/>
+            <a:srgbClr val="8B5CF6"/>
           </a:solidFill>
           <a:ln/>
         </p:spPr>
@@ -8201,7 +8201,7 @@
             <a:r>
               <a:rPr lang="en-US" sz="1800" b="1" dirty="0">
                 <a:solidFill>
-                  <a:srgbClr val="7C3AED"/>
+                  <a:srgbClr val="8B5CF6"/>
                 </a:solidFill>
                 <a:latin typeface="Trebuchet MS" pitchFamily="34" charset="0"/>
                 <a:ea typeface="Trebuchet MS" pitchFamily="34" charset="-122"/>
@@ -8243,7 +8243,7 @@
             <a:r>
               <a:rPr lang="en-US" sz="1400" dirty="0">
                 <a:solidFill>
-                  <a:srgbClr val="566377"/>
+                  <a:srgbClr val="9FB0CC"/>
                 </a:solidFill>
                 <a:latin typeface="Calibri" pitchFamily="34" charset="0"/>
                 <a:ea typeface="Calibri" pitchFamily="34" charset="-122"/>
@@ -8270,18 +8270,18 @@
             <a:avLst/>
           </a:prstGeom>
           <a:solidFill>
-            <a:srgbClr val="FFFFFF"/>
+            <a:srgbClr val="141F38"/>
           </a:solidFill>
           <a:ln w="12700">
             <a:solidFill>
-              <a:srgbClr val="E3E9F1"/>
+              <a:srgbClr val="2A3A59"/>
             </a:solidFill>
             <a:prstDash val="solid"/>
           </a:ln>
           <a:effectLst>
-            <a:outerShdw sx="100000" sy="100000" kx="0" ky="0" algn="bl" rotWithShape="0" blurRad="114300" dist="38100" dir="5400000">
-              <a:srgbClr val="0F172A">
-                <a:alpha val="10000"/>
+            <a:outerShdw sx="100000" sy="100000" kx="0" ky="0" algn="bl" rotWithShape="0" blurRad="127000" dist="38100" dir="5400000">
+              <a:srgbClr val="000000">
+                <a:alpha val="35000"/>
               </a:srgbClr>
             </a:outerShdw>
           </a:effectLst>
@@ -8302,7 +8302,7 @@
             <a:avLst/>
           </a:prstGeom>
           <a:solidFill>
-            <a:srgbClr val="D97706"/>
+            <a:srgbClr val="F59E0B"/>
           </a:solidFill>
           <a:ln/>
         </p:spPr>
@@ -8334,7 +8334,7 @@
             <a:r>
               <a:rPr lang="en-US" sz="1800" b="1" dirty="0">
                 <a:solidFill>
-                  <a:srgbClr val="D97706"/>
+                  <a:srgbClr val="F59E0B"/>
                 </a:solidFill>
                 <a:latin typeface="Trebuchet MS" pitchFamily="34" charset="0"/>
                 <a:ea typeface="Trebuchet MS" pitchFamily="34" charset="-122"/>
@@ -8376,7 +8376,7 @@
             <a:r>
               <a:rPr lang="en-US" sz="1400" dirty="0">
                 <a:solidFill>
-                  <a:srgbClr val="566377"/>
+                  <a:srgbClr val="9FB0CC"/>
                 </a:solidFill>
                 <a:latin typeface="Calibri" pitchFamily="34" charset="0"/>
                 <a:ea typeface="Calibri" pitchFamily="34" charset="-122"/>
@@ -8403,18 +8403,18 @@
             <a:avLst/>
           </a:prstGeom>
           <a:solidFill>
-            <a:srgbClr val="FFFFFF"/>
+            <a:srgbClr val="141F38"/>
           </a:solidFill>
           <a:ln w="12700">
             <a:solidFill>
-              <a:srgbClr val="E3E9F1"/>
+              <a:srgbClr val="2A3A59"/>
             </a:solidFill>
             <a:prstDash val="solid"/>
           </a:ln>
           <a:effectLst>
-            <a:outerShdw sx="100000" sy="100000" kx="0" ky="0" algn="bl" rotWithShape="0" blurRad="114300" dist="38100" dir="5400000">
-              <a:srgbClr val="0F172A">
-                <a:alpha val="10000"/>
+            <a:outerShdw sx="100000" sy="100000" kx="0" ky="0" algn="bl" rotWithShape="0" blurRad="127000" dist="38100" dir="5400000">
+              <a:srgbClr val="000000">
+                <a:alpha val="35000"/>
               </a:srgbClr>
             </a:outerShdw>
           </a:effectLst>
@@ -8435,7 +8435,7 @@
             <a:avLst/>
           </a:prstGeom>
           <a:solidFill>
-            <a:srgbClr val="0D9488"/>
+            <a:srgbClr val="2DD4BF"/>
           </a:solidFill>
           <a:ln/>
         </p:spPr>
@@ -8467,7 +8467,7 @@
             <a:r>
               <a:rPr lang="en-US" sz="1800" b="1" dirty="0">
                 <a:solidFill>
-                  <a:srgbClr val="0D9488"/>
+                  <a:srgbClr val="2DD4BF"/>
                 </a:solidFill>
                 <a:latin typeface="Trebuchet MS" pitchFamily="34" charset="0"/>
                 <a:ea typeface="Trebuchet MS" pitchFamily="34" charset="-122"/>
@@ -8509,7 +8509,7 @@
             <a:r>
               <a:rPr lang="en-US" sz="1400" dirty="0">
                 <a:solidFill>
-                  <a:srgbClr val="566377"/>
+                  <a:srgbClr val="9FB0CC"/>
                 </a:solidFill>
                 <a:latin typeface="Calibri" pitchFamily="34" charset="0"/>
                 <a:ea typeface="Calibri" pitchFamily="34" charset="-122"/>
@@ -8536,18 +8536,18 @@
             <a:avLst/>
           </a:prstGeom>
           <a:solidFill>
-            <a:srgbClr val="FFFFFF"/>
+            <a:srgbClr val="141F38"/>
           </a:solidFill>
           <a:ln w="12700">
             <a:solidFill>
-              <a:srgbClr val="E3E9F1"/>
+              <a:srgbClr val="2A3A59"/>
             </a:solidFill>
             <a:prstDash val="solid"/>
           </a:ln>
           <a:effectLst>
-            <a:outerShdw sx="100000" sy="100000" kx="0" ky="0" algn="bl" rotWithShape="0" blurRad="114300" dist="38100" dir="5400000">
-              <a:srgbClr val="0F172A">
-                <a:alpha val="10000"/>
+            <a:outerShdw sx="100000" sy="100000" kx="0" ky="0" algn="bl" rotWithShape="0" blurRad="127000" dist="38100" dir="5400000">
+              <a:srgbClr val="000000">
+                <a:alpha val="35000"/>
               </a:srgbClr>
             </a:outerShdw>
           </a:effectLst>
@@ -8568,7 +8568,7 @@
             <a:avLst/>
           </a:prstGeom>
           <a:solidFill>
-            <a:srgbClr val="E11D48"/>
+            <a:srgbClr val="F43F5E"/>
           </a:solidFill>
           <a:ln/>
         </p:spPr>
@@ -8600,7 +8600,7 @@
             <a:r>
               <a:rPr lang="en-US" sz="1800" b="1" dirty="0">
                 <a:solidFill>
-                  <a:srgbClr val="E11D48"/>
+                  <a:srgbClr val="F43F5E"/>
                 </a:solidFill>
                 <a:latin typeface="Trebuchet MS" pitchFamily="34" charset="0"/>
                 <a:ea typeface="Trebuchet MS" pitchFamily="34" charset="-122"/>
@@ -8642,7 +8642,7 @@
             <a:r>
               <a:rPr lang="en-US" sz="1400" dirty="0">
                 <a:solidFill>
-                  <a:srgbClr val="566377"/>
+                  <a:srgbClr val="9FB0CC"/>
                 </a:solidFill>
                 <a:latin typeface="Calibri" pitchFamily="34" charset="0"/>
                 <a:ea typeface="Calibri" pitchFamily="34" charset="-122"/>
@@ -8668,7 +8668,7 @@
     <p:bg>
       <p:bgPr>
         <a:solidFill>
-          <a:srgbClr val="F7FAFC"/>
+          <a:srgbClr val="0B1220"/>
         </a:solidFill>
       </p:bgPr>
     </p:bg>
@@ -8713,7 +8713,7 @@
             <a:r>
               <a:rPr lang="en-US" sz="1250" b="1" spc="200" kern="0" dirty="0">
                 <a:solidFill>
-                  <a:srgbClr val="0D9488"/>
+                  <a:srgbClr val="2DD4BF"/>
                 </a:solidFill>
                 <a:latin typeface="Consolas" pitchFamily="34" charset="0"/>
                 <a:ea typeface="Consolas" pitchFamily="34" charset="-122"/>
@@ -8727,7 +8727,7 @@
             <a:r>
               <a:rPr lang="en-US" sz="1250" spc="200" kern="0" dirty="0">
                 <a:solidFill>
-                  <a:srgbClr val="566377"/>
+                  <a:srgbClr val="9FB0CC"/>
                 </a:solidFill>
                 <a:latin typeface="Consolas" pitchFamily="34" charset="0"/>
                 <a:ea typeface="Consolas" pitchFamily="34" charset="-122"/>
@@ -8766,7 +8766,7 @@
             <a:r>
               <a:rPr lang="en-US" sz="3100" b="1" dirty="0">
                 <a:solidFill>
-                  <a:srgbClr val="0F172A"/>
+                  <a:srgbClr val="EAF1FB"/>
                 </a:solidFill>
                 <a:latin typeface="Trebuchet MS" pitchFamily="34" charset="0"/>
                 <a:ea typeface="Trebuchet MS" pitchFamily="34" charset="-122"/>
@@ -8793,18 +8793,18 @@
             <a:avLst/>
           </a:prstGeom>
           <a:solidFill>
-            <a:srgbClr val="FFFFFF"/>
+            <a:srgbClr val="141F38"/>
           </a:solidFill>
           <a:ln w="12700">
             <a:solidFill>
-              <a:srgbClr val="E3E9F1"/>
+              <a:srgbClr val="2A3A59"/>
             </a:solidFill>
             <a:prstDash val="solid"/>
           </a:ln>
           <a:effectLst>
-            <a:outerShdw sx="100000" sy="100000" kx="0" ky="0" algn="bl" rotWithShape="0" blurRad="114300" dist="38100" dir="5400000">
-              <a:srgbClr val="0F172A">
-                <a:alpha val="10000"/>
+            <a:outerShdw sx="100000" sy="100000" kx="0" ky="0" algn="bl" rotWithShape="0" blurRad="127000" dist="38100" dir="5400000">
+              <a:srgbClr val="000000">
+                <a:alpha val="35000"/>
               </a:srgbClr>
             </a:outerShdw>
           </a:effectLst>
@@ -8825,7 +8825,7 @@
             <a:avLst/>
           </a:prstGeom>
           <a:solidFill>
-            <a:srgbClr val="0D9488"/>
+            <a:srgbClr val="2DD4BF"/>
           </a:solidFill>
           <a:ln/>
         </p:spPr>
@@ -8857,7 +8857,7 @@
             <a:r>
               <a:rPr lang="en-US" sz="1900" b="1" dirty="0">
                 <a:solidFill>
-                  <a:srgbClr val="0F172A"/>
+                  <a:srgbClr val="EAF1FB"/>
                 </a:solidFill>
                 <a:latin typeface="Trebuchet MS" pitchFamily="34" charset="0"/>
                 <a:ea typeface="Trebuchet MS" pitchFamily="34" charset="-122"/>
@@ -8903,7 +8903,7 @@
             <a:r>
               <a:rPr lang="en-US" sz="1450" dirty="0">
                 <a:solidFill>
-                  <a:srgbClr val="566377"/>
+                  <a:srgbClr val="9FB0CC"/>
                 </a:solidFill>
                 <a:latin typeface="Calibri" pitchFamily="34" charset="0"/>
                 <a:ea typeface="Calibri" pitchFamily="34" charset="-122"/>
@@ -8927,7 +8927,7 @@
             <a:r>
               <a:rPr lang="en-US" sz="1450" dirty="0">
                 <a:solidFill>
-                  <a:srgbClr val="566377"/>
+                  <a:srgbClr val="9FB0CC"/>
                 </a:solidFill>
                 <a:latin typeface="Calibri" pitchFamily="34" charset="0"/>
                 <a:ea typeface="Calibri" pitchFamily="34" charset="-122"/>
@@ -8951,7 +8951,7 @@
             <a:r>
               <a:rPr lang="en-US" sz="1450" dirty="0">
                 <a:solidFill>
-                  <a:srgbClr val="566377"/>
+                  <a:srgbClr val="9FB0CC"/>
                 </a:solidFill>
                 <a:latin typeface="Calibri" pitchFamily="34" charset="0"/>
                 <a:ea typeface="Calibri" pitchFamily="34" charset="-122"/>
@@ -8978,18 +8978,18 @@
             <a:avLst/>
           </a:prstGeom>
           <a:solidFill>
-            <a:srgbClr val="FFFFFF"/>
+            <a:srgbClr val="141F38"/>
           </a:solidFill>
           <a:ln w="12700">
             <a:solidFill>
-              <a:srgbClr val="E3E9F1"/>
+              <a:srgbClr val="2A3A59"/>
             </a:solidFill>
             <a:prstDash val="solid"/>
           </a:ln>
           <a:effectLst>
-            <a:outerShdw sx="100000" sy="100000" kx="0" ky="0" algn="bl" rotWithShape="0" blurRad="114300" dist="38100" dir="5400000">
-              <a:srgbClr val="0F172A">
-                <a:alpha val="10000"/>
+            <a:outerShdw sx="100000" sy="100000" kx="0" ky="0" algn="bl" rotWithShape="0" blurRad="127000" dist="38100" dir="5400000">
+              <a:srgbClr val="000000">
+                <a:alpha val="35000"/>
               </a:srgbClr>
             </a:outerShdw>
           </a:effectLst>
@@ -9010,7 +9010,7 @@
             <a:avLst/>
           </a:prstGeom>
           <a:solidFill>
-            <a:srgbClr val="E11D48"/>
+            <a:srgbClr val="F43F5E"/>
           </a:solidFill>
           <a:ln/>
         </p:spPr>
@@ -9042,7 +9042,7 @@
             <a:r>
               <a:rPr lang="en-US" sz="1900" b="1" dirty="0">
                 <a:solidFill>
-                  <a:srgbClr val="0F172A"/>
+                  <a:srgbClr val="EAF1FB"/>
                 </a:solidFill>
                 <a:latin typeface="Trebuchet MS" pitchFamily="34" charset="0"/>
                 <a:ea typeface="Trebuchet MS" pitchFamily="34" charset="-122"/>
@@ -9084,7 +9084,7 @@
             <a:r>
               <a:rPr lang="en-US" sz="1450" dirty="0">
                 <a:solidFill>
-                  <a:srgbClr val="566377"/>
+                  <a:srgbClr val="9FB0CC"/>
                 </a:solidFill>
                 <a:latin typeface="Calibri" pitchFamily="34" charset="0"/>
                 <a:ea typeface="Calibri" pitchFamily="34" charset="-122"/>
@@ -9130,7 +9130,7 @@
             <a:r>
               <a:rPr lang="en-US" sz="1400" dirty="0">
                 <a:solidFill>
-                  <a:srgbClr val="0F172A"/>
+                  <a:srgbClr val="EAF1FB"/>
                 </a:solidFill>
                 <a:latin typeface="Calibri" pitchFamily="34" charset="0"/>
                 <a:ea typeface="Calibri" pitchFamily="34" charset="-122"/>
@@ -9154,7 +9154,7 @@
             <a:r>
               <a:rPr lang="en-US" sz="1400" dirty="0">
                 <a:solidFill>
-                  <a:srgbClr val="0F172A"/>
+                  <a:srgbClr val="EAF1FB"/>
                 </a:solidFill>
                 <a:latin typeface="Calibri" pitchFamily="34" charset="0"/>
                 <a:ea typeface="Calibri" pitchFamily="34" charset="-122"/>
@@ -9193,7 +9193,7 @@
             <a:r>
               <a:rPr lang="en-US" sz="1400" b="1" i="1" dirty="0">
                 <a:solidFill>
-                  <a:srgbClr val="E11D48"/>
+                  <a:srgbClr val="F43F5E"/>
                 </a:solidFill>
                 <a:latin typeface="Calibri" pitchFamily="34" charset="0"/>
                 <a:ea typeface="Calibri" pitchFamily="34" charset="-122"/>
@@ -9219,7 +9219,7 @@
     <p:bg>
       <p:bgPr>
         <a:solidFill>
-          <a:srgbClr val="F7FAFC"/>
+          <a:srgbClr val="0B1220"/>
         </a:solidFill>
       </p:bgPr>
     </p:bg>
@@ -9264,7 +9264,7 @@
             <a:r>
               <a:rPr lang="en-US" sz="1250" b="1" spc="200" kern="0" dirty="0">
                 <a:solidFill>
-                  <a:srgbClr val="0D9488"/>
+                  <a:srgbClr val="2DD4BF"/>
                 </a:solidFill>
                 <a:latin typeface="Consolas" pitchFamily="34" charset="0"/>
                 <a:ea typeface="Consolas" pitchFamily="34" charset="-122"/>
@@ -9278,7 +9278,7 @@
             <a:r>
               <a:rPr lang="en-US" sz="1250" spc="200" kern="0" dirty="0">
                 <a:solidFill>
-                  <a:srgbClr val="566377"/>
+                  <a:srgbClr val="9FB0CC"/>
                 </a:solidFill>
                 <a:latin typeface="Consolas" pitchFamily="34" charset="0"/>
                 <a:ea typeface="Consolas" pitchFamily="34" charset="-122"/>
@@ -9317,7 +9317,7 @@
             <a:r>
               <a:rPr lang="en-US" sz="3100" b="1" dirty="0">
                 <a:solidFill>
-                  <a:srgbClr val="0F172A"/>
+                  <a:srgbClr val="EAF1FB"/>
                 </a:solidFill>
                 <a:latin typeface="Trebuchet MS" pitchFamily="34" charset="0"/>
                 <a:ea typeface="Trebuchet MS" pitchFamily="34" charset="-122"/>
@@ -9356,7 +9356,7 @@
             <a:r>
               <a:rPr lang="en-US" sz="1500" i="1" dirty="0">
                 <a:solidFill>
-                  <a:srgbClr val="566377"/>
+                  <a:srgbClr val="9FB0CC"/>
                 </a:solidFill>
                 <a:latin typeface="Calibri" pitchFamily="34" charset="0"/>
                 <a:ea typeface="Calibri" pitchFamily="34" charset="-122"/>
@@ -9383,18 +9383,18 @@
             <a:avLst/>
           </a:prstGeom>
           <a:solidFill>
-            <a:srgbClr val="FFFFFF"/>
+            <a:srgbClr val="141F38"/>
           </a:solidFill>
           <a:ln w="12700">
             <a:solidFill>
-              <a:srgbClr val="E3E9F1"/>
+              <a:srgbClr val="2A3A59"/>
             </a:solidFill>
             <a:prstDash val="solid"/>
           </a:ln>
           <a:effectLst>
-            <a:outerShdw sx="100000" sy="100000" kx="0" ky="0" algn="bl" rotWithShape="0" blurRad="114300" dist="38100" dir="5400000">
-              <a:srgbClr val="0F172A">
-                <a:alpha val="10000"/>
+            <a:outerShdw sx="100000" sy="100000" kx="0" ky="0" algn="bl" rotWithShape="0" blurRad="127000" dist="38100" dir="5400000">
+              <a:srgbClr val="000000">
+                <a:alpha val="35000"/>
               </a:srgbClr>
             </a:outerShdw>
           </a:effectLst>
@@ -9415,7 +9415,7 @@
             <a:avLst/>
           </a:prstGeom>
           <a:solidFill>
-            <a:srgbClr val="D97706"/>
+            <a:srgbClr val="F59E0B"/>
           </a:solidFill>
           <a:ln/>
         </p:spPr>
@@ -9447,7 +9447,7 @@
             <a:r>
               <a:rPr lang="en-US" sz="2800" b="1" dirty="0">
                 <a:solidFill>
-                  <a:srgbClr val="D97706"/>
+                  <a:srgbClr val="F59E0B"/>
                 </a:solidFill>
                 <a:latin typeface="Trebuchet MS" pitchFamily="34" charset="0"/>
                 <a:ea typeface="Trebuchet MS" pitchFamily="34" charset="-122"/>
@@ -9486,7 +9486,7 @@
             <a:r>
               <a:rPr lang="en-US" sz="2000" b="1" dirty="0">
                 <a:solidFill>
-                  <a:srgbClr val="0F172A"/>
+                  <a:srgbClr val="EAF1FB"/>
                 </a:solidFill>
                 <a:latin typeface="Trebuchet MS" pitchFamily="34" charset="0"/>
                 <a:ea typeface="Trebuchet MS" pitchFamily="34" charset="-122"/>
@@ -9528,7 +9528,7 @@
             <a:r>
               <a:rPr lang="en-US" sz="1450" dirty="0">
                 <a:solidFill>
-                  <a:srgbClr val="566377"/>
+                  <a:srgbClr val="9FB0CC"/>
                 </a:solidFill>
                 <a:latin typeface="Calibri" pitchFamily="34" charset="0"/>
                 <a:ea typeface="Calibri" pitchFamily="34" charset="-122"/>
@@ -9555,18 +9555,18 @@
             <a:avLst/>
           </a:prstGeom>
           <a:solidFill>
-            <a:srgbClr val="FFFFFF"/>
+            <a:srgbClr val="141F38"/>
           </a:solidFill>
           <a:ln w="12700">
             <a:solidFill>
-              <a:srgbClr val="E3E9F1"/>
+              <a:srgbClr val="2A3A59"/>
             </a:solidFill>
             <a:prstDash val="solid"/>
           </a:ln>
           <a:effectLst>
-            <a:outerShdw sx="100000" sy="100000" kx="0" ky="0" algn="bl" rotWithShape="0" blurRad="114300" dist="38100" dir="5400000">
-              <a:srgbClr val="0F172A">
-                <a:alpha val="10000"/>
+            <a:outerShdw sx="100000" sy="100000" kx="0" ky="0" algn="bl" rotWithShape="0" blurRad="127000" dist="38100" dir="5400000">
+              <a:srgbClr val="000000">
+                <a:alpha val="35000"/>
               </a:srgbClr>
             </a:outerShdw>
           </a:effectLst>
@@ -9587,7 +9587,7 @@
             <a:avLst/>
           </a:prstGeom>
           <a:solidFill>
-            <a:srgbClr val="7C3AED"/>
+            <a:srgbClr val="8B5CF6"/>
           </a:solidFill>
           <a:ln/>
         </p:spPr>
@@ -9619,7 +9619,7 @@
             <a:r>
               <a:rPr lang="en-US" sz="2800" b="1" dirty="0">
                 <a:solidFill>
-                  <a:srgbClr val="7C3AED"/>
+                  <a:srgbClr val="8B5CF6"/>
                 </a:solidFill>
                 <a:latin typeface="Trebuchet MS" pitchFamily="34" charset="0"/>
                 <a:ea typeface="Trebuchet MS" pitchFamily="34" charset="-122"/>
@@ -9658,7 +9658,7 @@
             <a:r>
               <a:rPr lang="en-US" sz="2000" b="1" dirty="0">
                 <a:solidFill>
-                  <a:srgbClr val="0F172A"/>
+                  <a:srgbClr val="EAF1FB"/>
                 </a:solidFill>
                 <a:latin typeface="Trebuchet MS" pitchFamily="34" charset="0"/>
                 <a:ea typeface="Trebuchet MS" pitchFamily="34" charset="-122"/>
@@ -9700,7 +9700,7 @@
             <a:r>
               <a:rPr lang="en-US" sz="1450" dirty="0">
                 <a:solidFill>
-                  <a:srgbClr val="566377"/>
+                  <a:srgbClr val="9FB0CC"/>
                 </a:solidFill>
                 <a:latin typeface="Calibri" pitchFamily="34" charset="0"/>
                 <a:ea typeface="Calibri" pitchFamily="34" charset="-122"/>
@@ -9727,18 +9727,18 @@
             <a:avLst/>
           </a:prstGeom>
           <a:solidFill>
-            <a:srgbClr val="FFFFFF"/>
+            <a:srgbClr val="141F38"/>
           </a:solidFill>
           <a:ln w="12700">
             <a:solidFill>
-              <a:srgbClr val="E3E9F1"/>
+              <a:srgbClr val="2A3A59"/>
             </a:solidFill>
             <a:prstDash val="solid"/>
           </a:ln>
           <a:effectLst>
-            <a:outerShdw sx="100000" sy="100000" kx="0" ky="0" algn="bl" rotWithShape="0" blurRad="114300" dist="38100" dir="5400000">
-              <a:srgbClr val="0F172A">
-                <a:alpha val="10000"/>
+            <a:outerShdw sx="100000" sy="100000" kx="0" ky="0" algn="bl" rotWithShape="0" blurRad="127000" dist="38100" dir="5400000">
+              <a:srgbClr val="000000">
+                <a:alpha val="35000"/>
               </a:srgbClr>
             </a:outerShdw>
           </a:effectLst>
@@ -9759,7 +9759,7 @@
             <a:avLst/>
           </a:prstGeom>
           <a:solidFill>
-            <a:srgbClr val="E11D48"/>
+            <a:srgbClr val="F43F5E"/>
           </a:solidFill>
           <a:ln/>
         </p:spPr>
@@ -9791,7 +9791,7 @@
             <a:r>
               <a:rPr lang="en-US" sz="2800" b="1" dirty="0">
                 <a:solidFill>
-                  <a:srgbClr val="E11D48"/>
+                  <a:srgbClr val="F43F5E"/>
                 </a:solidFill>
                 <a:latin typeface="Trebuchet MS" pitchFamily="34" charset="0"/>
                 <a:ea typeface="Trebuchet MS" pitchFamily="34" charset="-122"/>
@@ -9830,7 +9830,7 @@
             <a:r>
               <a:rPr lang="en-US" sz="2000" b="1" dirty="0">
                 <a:solidFill>
-                  <a:srgbClr val="0F172A"/>
+                  <a:srgbClr val="EAF1FB"/>
                 </a:solidFill>
                 <a:latin typeface="Trebuchet MS" pitchFamily="34" charset="0"/>
                 <a:ea typeface="Trebuchet MS" pitchFamily="34" charset="-122"/>
@@ -9872,7 +9872,7 @@
             <a:r>
               <a:rPr lang="en-US" sz="1450" dirty="0">
                 <a:solidFill>
-                  <a:srgbClr val="566377"/>
+                  <a:srgbClr val="9FB0CC"/>
                 </a:solidFill>
                 <a:latin typeface="Calibri" pitchFamily="34" charset="0"/>
                 <a:ea typeface="Calibri" pitchFamily="34" charset="-122"/>

</xml_diff>